<commit_message>
Rewrite opening slide text in presentation style
Co-Authored-By: Claude Opus 5.5 <noreply@anthropic.com>
Claude-Session: https://claude.ai/code/session_01K1zKozKMB1GPwZUgJWygu6
</commit_message>
<xml_diff>
--- a/tissue_sales_roleplay.pptx
+++ b/tissue_sales_roleplay.pptx
@@ -114,38 +114,38 @@
   <p:extLst>
     <p:ext uri="{521415D9-36F7-43E2-AB2F-B90AF26B5E84}">
       <p14:sectionLst xmlns:p14="http://schemas.microsoft.com/office/powerpoint/2010/main">
-        <p14:section name="導入" id="{d6b4701b-bb53-966e-02ca-1711f26a34e7}">
+        <p14:section name="導入" id="{efdb0549-c016-f8c4-f44d-24bc691fe559}">
           <p14:sldIdLst>
             <p14:sldId id="256"/>
           </p14:sldIdLst>
         </p14:section>
-        <p14:section name="ヒアリング" id="{0fe7e03c-04a6-d39b-bdd2-0693328c4961}">
+        <p14:section name="ヒアリング" id="{b855579e-5d02-fc39-58f1-29e8154526bf}">
           <p14:sldIdLst>
             <p14:sldId id="257"/>
           </p14:sldIdLst>
         </p14:section>
-        <p14:section name="商品提案" id="{4ee19c5a-3ae3-e4e4-e306-0b98979afc8b}">
+        <p14:section name="商品提案" id="{b4fb0f8e-0c4d-6bec-efda-9153714812f6}">
           <p14:sldIdLst>
             <p14:sldId id="258"/>
             <p14:sldId id="259"/>
           </p14:sldIdLst>
         </p14:section>
-        <p14:section name="使い分け" id="{4ef1db2d-ec25-25b0-edf1-c2d51c393ba0}">
+        <p14:section name="使い分け" id="{90bd8987-e554-68eb-9222-e75d436cc849}">
           <p14:sldIdLst>
             <p14:sldId id="260"/>
           </p14:sldIdLst>
         </p14:section>
-        <p14:section name="クロージング" id="{85f3d9b1-1dbc-c1d7-6853-28b7fec7ea6e}">
+        <p14:section name="クロージング" id="{6282efb0-a891-7b6f-2f2c-ebc46dcb2f1d}">
           <p14:sldIdLst>
             <p14:sldId id="261"/>
           </p14:sldIdLst>
         </p14:section>
-        <p14:section name="振り返り" id="{37df66da-5f5a-d4cc-7581-a5a5a438766b}">
+        <p14:section name="振り返り" id="{cedebb28-3dee-c8af-2197-f237513ac78c}">
           <p14:sldIdLst>
             <p14:sldId id="262"/>
           </p14:sldIdLst>
         </p14:section>
-        <p14:section name="まとめ" id="{2879df30-4498-cf9e-d982-c2943ecc5877}">
+        <p14:section name="まとめ" id="{3c7dff77-96ef-9c91-22c6-af972734d167}">
           <p14:sldIdLst>
             <p14:sldId id="263"/>
           </p14:sldIdLst>
@@ -2127,7 +2127,7 @@
                   <a:schemeClr val="accent2"/>
                 </a:solidFill>
               </a:rPr>
-              <a:t>① 導入・ヒアリング</a:t>
+              <a:t>① ティッシュ選びのポイント</a:t>
             </a:r>
             <a:endParaRPr lang="en-US" sz="1200" dirty="0"/>
           </a:p>
@@ -2165,7 +2165,7 @@
                   <a:schemeClr val="tx2"/>
                 </a:solidFill>
               </a:rPr>
-              <a:t>まずは、お客様が大切にしていることを伺う</a:t>
+              <a:t>ティッシュ選びは「価格」と「使う場面」が決め手</a:t>
             </a:r>
             <a:endParaRPr lang="en-US" sz="2600" dirty="0"/>
           </a:p>
@@ -2173,27 +2173,56 @@
       </p:sp>
       <p:sp>
         <p:nvSpPr>
-          <p:cNvPr id="4" name="Sales circle"/>
+          <p:cNvPr id="4" name="Point card"/>
           <p:cNvSpPr/>
           <p:nvPr/>
         </p:nvSpPr>
         <p:spPr>
           <a:xfrm>
             <a:off x="457200" y="1371600"/>
-            <a:ext cx="502920" cy="502920"/>
+            <a:ext cx="5486400" cy="1371600"/>
+          </a:xfrm>
+          <a:prstGeom prst="roundRect">
+            <a:avLst>
+              <a:gd name="adj" fmla="val 8000"/>
+            </a:avLst>
+          </a:prstGeom>
+          <a:solidFill>
+            <a:schemeClr val="bg2"/>
+          </a:solidFill>
+          <a:ln/>
+          <a:effectLst>
+            <a:outerShdw sx="100000" sy="100000" kx="0" ky="0" algn="bl" rotWithShape="0" blurRad="76200" dist="25400" dir="5400000">
+              <a:srgbClr val="000000">
+                <a:alpha val="12000"/>
+              </a:srgbClr>
+            </a:outerShdw>
+          </a:effectLst>
+        </p:spPr>
+      </p:sp>
+      <p:sp>
+        <p:nvSpPr>
+          <p:cNvPr id="5" name="選ぶときの基準 circle"/>
+          <p:cNvSpPr/>
+          <p:nvPr/>
+        </p:nvSpPr>
+        <p:spPr>
+          <a:xfrm>
+            <a:off x="731520" y="1645920"/>
+            <a:ext cx="822960" cy="822960"/>
           </a:xfrm>
           <a:prstGeom prst="ellipse">
             <a:avLst/>
           </a:prstGeom>
           <a:solidFill>
-            <a:schemeClr val="tx2"/>
+            <a:schemeClr val="accent3"/>
           </a:solidFill>
           <a:ln/>
         </p:spPr>
       </p:sp>
       <p:pic>
         <p:nvPicPr>
-          <p:cNvPr id="5" name="Sales icon" descr="Sales">    </p:cNvPr>
+          <p:cNvPr id="6" name="選ぶときの基準 icon" descr="選ぶときの基準">    </p:cNvPr>
           <p:cNvPicPr>
             <a:picLocks noChangeAspect="1"/>
           </p:cNvPicPr>
@@ -2207,8 +2236,8 @@
         </p:blipFill>
         <p:spPr>
           <a:xfrm>
-            <a:off x="582930" y="1497330"/>
-            <a:ext cx="251460" cy="251460"/>
+            <a:off x="937260" y="1851660"/>
+            <a:ext cx="411480" cy="411480"/>
           </a:xfrm>
           <a:prstGeom prst="rect">
             <a:avLst/>
@@ -2217,18 +2246,90 @@
       </p:pic>
       <p:sp>
         <p:nvSpPr>
-          <p:cNvPr id="6" name="Question bubble"/>
+          <p:cNvPr id="7" name="Text 4"/>
+          <p:cNvSpPr txBox="1"/>
+          <p:nvPr/>
+        </p:nvSpPr>
+        <p:spPr>
+          <a:xfrm>
+            <a:off x="1828800" y="1600200"/>
+            <a:ext cx="3931920" cy="365760"/>
+          </a:xfrm>
+          <a:prstGeom prst="rect">
+            <a:avLst/>
+          </a:prstGeom>
+          <a:noFill/>
+          <a:ln/>
+        </p:spPr>
+        <p:txBody>
+          <a:bodyPr wrap="square" lIns="0" tIns="0" rIns="0" bIns="0" rtlCol="0" anchor="t"/>
+          <a:lstStyle/>
+          <a:p>
+            <a:pPr indent="0" marL="0">
+              <a:buNone/>
+            </a:pPr>
+            <a:r>
+              <a:rPr lang="en-US" sz="1600" b="1" dirty="0">
+                <a:solidFill>
+                  <a:schemeClr val="tx2"/>
+                </a:solidFill>
+              </a:rPr>
+              <a:t>選ぶときの基準</a:t>
+            </a:r>
+            <a:endParaRPr lang="en-US" sz="1600" dirty="0"/>
+          </a:p>
+        </p:txBody>
+      </p:sp>
+      <p:sp>
+        <p:nvSpPr>
+          <p:cNvPr id="8" name="Text 5"/>
+          <p:cNvSpPr txBox="1"/>
+          <p:nvPr/>
+        </p:nvSpPr>
+        <p:spPr>
+          <a:xfrm>
+            <a:off x="1828800" y="2011680"/>
+            <a:ext cx="3931920" cy="640080"/>
+          </a:xfrm>
+          <a:prstGeom prst="rect">
+            <a:avLst/>
+          </a:prstGeom>
+          <a:noFill/>
+          <a:ln/>
+        </p:spPr>
+        <p:txBody>
+          <a:bodyPr wrap="square" lIns="0" tIns="0" rIns="0" bIns="0" rtlCol="0" anchor="t"/>
+          <a:lstStyle/>
+          <a:p>
+            <a:pPr indent="0" marL="0">
+              <a:buNone/>
+            </a:pPr>
+            <a:r>
+              <a:rPr lang="en-US" sz="1300" dirty="0">
+                <a:solidFill>
+                  <a:schemeClr val="tx1"/>
+                </a:solidFill>
+              </a:rPr>
+              <a:t>毎日使う消耗品だからこそ、多くの方が「価格」を重視しています</a:t>
+            </a:r>
+            <a:endParaRPr lang="en-US" sz="1300" dirty="0"/>
+          </a:p>
+        </p:txBody>
+      </p:sp>
+      <p:sp>
+        <p:nvSpPr>
+          <p:cNvPr id="9" name="Point card"/>
           <p:cNvSpPr/>
           <p:nvPr/>
         </p:nvSpPr>
         <p:spPr>
           <a:xfrm>
-            <a:off x="1097280" y="1371600"/>
-            <a:ext cx="4206240" cy="685800"/>
+            <a:off x="457200" y="2971800"/>
+            <a:ext cx="5486400" cy="1371600"/>
           </a:xfrm>
           <a:prstGeom prst="roundRect">
             <a:avLst>
-              <a:gd name="adj" fmla="val 16000"/>
+              <a:gd name="adj" fmla="val 8000"/>
             </a:avLst>
           </a:prstGeom>
           <a:solidFill>
@@ -2246,58 +2347,138 @@
       </p:sp>
       <p:sp>
         <p:nvSpPr>
-          <p:cNvPr id="7" name="Text 4"/>
+          <p:cNvPr id="10" name="よく使う場面 circle"/>
+          <p:cNvSpPr/>
+          <p:nvPr/>
+        </p:nvSpPr>
+        <p:spPr>
+          <a:xfrm>
+            <a:off x="731520" y="3246120"/>
+            <a:ext cx="822960" cy="822960"/>
+          </a:xfrm>
+          <a:prstGeom prst="ellipse">
+            <a:avLst/>
+          </a:prstGeom>
+          <a:solidFill>
+            <a:schemeClr val="accent2"/>
+          </a:solidFill>
+          <a:ln/>
+        </p:spPr>
+      </p:sp>
+      <p:pic>
+        <p:nvPicPr>
+          <p:cNvPr id="11" name="よく使う場面 icon" descr="よく使う場面">    </p:cNvPr>
+          <p:cNvPicPr>
+            <a:picLocks noChangeAspect="1"/>
+          </p:cNvPicPr>
+          <p:nvPr/>
+        </p:nvPicPr>
+        <p:blipFill>
+          <a:blip r:embed="rId2"/>
+          <a:stretch>
+            <a:fillRect/>
+          </a:stretch>
+        </p:blipFill>
+        <p:spPr>
+          <a:xfrm>
+            <a:off x="937260" y="3451860"/>
+            <a:ext cx="411480" cy="411480"/>
+          </a:xfrm>
+          <a:prstGeom prst="rect">
+            <a:avLst/>
+          </a:prstGeom>
+        </p:spPr>
+      </p:pic>
+      <p:sp>
+        <p:nvSpPr>
+          <p:cNvPr id="12" name="Text 8"/>
           <p:cNvSpPr txBox="1"/>
           <p:nvPr/>
         </p:nvSpPr>
         <p:spPr>
           <a:xfrm>
-            <a:off x="1234440" y="1371600"/>
-            <a:ext cx="3931920" cy="685800"/>
-          </a:xfrm>
-          <a:prstGeom prst="rect">
-            <a:avLst/>
-          </a:prstGeom>
-          <a:noFill/>
-          <a:ln/>
-        </p:spPr>
-        <p:txBody>
-          <a:bodyPr wrap="square" lIns="0" tIns="0" rIns="0" bIns="0" rtlCol="0" anchor="ctr"/>
+            <a:off x="1828800" y="3200400"/>
+            <a:ext cx="3931920" cy="365760"/>
+          </a:xfrm>
+          <a:prstGeom prst="rect">
+            <a:avLst/>
+          </a:prstGeom>
+          <a:noFill/>
+          <a:ln/>
+        </p:spPr>
+        <p:txBody>
+          <a:bodyPr wrap="square" lIns="0" tIns="0" rIns="0" bIns="0" rtlCol="0" anchor="t"/>
           <a:lstStyle/>
           <a:p>
             <a:pPr indent="0" marL="0">
               <a:buNone/>
             </a:pPr>
             <a:r>
-              <a:rPr lang="en-US" sz="1200" dirty="0">
+              <a:rPr lang="en-US" sz="1600" b="1" dirty="0">
+                <a:solidFill>
+                  <a:schemeClr val="tx2"/>
+                </a:solidFill>
+              </a:rPr>
+              <a:t>よく使う場面</a:t>
+            </a:r>
+            <a:endParaRPr lang="en-US" sz="1600" dirty="0"/>
+          </a:p>
+        </p:txBody>
+      </p:sp>
+      <p:sp>
+        <p:nvSpPr>
+          <p:cNvPr id="13" name="Text 9"/>
+          <p:cNvSpPr txBox="1"/>
+          <p:nvPr/>
+        </p:nvSpPr>
+        <p:spPr>
+          <a:xfrm>
+            <a:off x="1828800" y="3611880"/>
+            <a:ext cx="3931920" cy="640080"/>
+          </a:xfrm>
+          <a:prstGeom prst="rect">
+            <a:avLst/>
+          </a:prstGeom>
+          <a:noFill/>
+          <a:ln/>
+        </p:spPr>
+        <p:txBody>
+          <a:bodyPr wrap="square" lIns="0" tIns="0" rIns="0" bIns="0" rtlCol="0" anchor="t"/>
+          <a:lstStyle/>
+          <a:p>
+            <a:pPr indent="0" marL="0">
+              <a:buNone/>
+            </a:pPr>
+            <a:r>
+              <a:rPr lang="en-US" sz="1300" dirty="0">
                 <a:solidFill>
                   <a:schemeClr val="tx1"/>
                 </a:solidFill>
               </a:rPr>
-              <a:t>普段ティッシュを購入される際は、価格と使い心地のどちらを重視されていますか？</a:t>
-            </a:r>
-            <a:endParaRPr lang="en-US" sz="1200" dirty="0"/>
-          </a:p>
-        </p:txBody>
-      </p:sp>
-      <p:sp>
-        <p:nvSpPr>
-          <p:cNvPr id="8" name="Answer bubble"/>
+              <a:t>お食事、お掃除、鼻をかむとき。場面によって求める使い心地は異なります</a:t>
+            </a:r>
+            <a:endParaRPr lang="en-US" sz="1300" dirty="0"/>
+          </a:p>
+        </p:txBody>
+      </p:sp>
+      <p:sp>
+        <p:nvSpPr>
+          <p:cNvPr id="14" name="Insight card"/>
           <p:cNvSpPr/>
           <p:nvPr/>
         </p:nvSpPr>
         <p:spPr>
           <a:xfrm>
-            <a:off x="1828800" y="2194560"/>
-            <a:ext cx="3474720" cy="457200"/>
+            <a:off x="6309360" y="1371600"/>
+            <a:ext cx="2377440" cy="2971800"/>
           </a:xfrm>
           <a:prstGeom prst="roundRect">
             <a:avLst>
-              <a:gd name="adj" fmla="val 24000"/>
+              <a:gd name="adj" fmla="val 4615"/>
             </a:avLst>
           </a:prstGeom>
           <a:solidFill>
-            <a:schemeClr val="accent3"/>
+            <a:schemeClr val="tx2"/>
           </a:solidFill>
           <a:ln/>
           <a:effectLst>
@@ -2309,109 +2490,9 @@
           </a:effectLst>
         </p:spPr>
       </p:sp>
-      <p:sp>
-        <p:nvSpPr>
-          <p:cNvPr id="9" name="Text 6"/>
-          <p:cNvSpPr txBox="1"/>
-          <p:nvPr/>
-        </p:nvSpPr>
-        <p:spPr>
-          <a:xfrm>
-            <a:off x="1920240" y="2194560"/>
-            <a:ext cx="3291840" cy="457200"/>
-          </a:xfrm>
-          <a:prstGeom prst="rect">
-            <a:avLst/>
-          </a:prstGeom>
-          <a:noFill/>
-          <a:ln/>
-        </p:spPr>
-        <p:txBody>
-          <a:bodyPr wrap="square" lIns="0" tIns="0" rIns="0" bIns="0" rtlCol="0" anchor="ctr"/>
-          <a:lstStyle/>
-          <a:p>
-            <a:pPr indent="0" marL="0">
-              <a:buNone/>
-            </a:pPr>
-            <a:r>
-              <a:rPr lang="en-US" sz="1300" b="1" dirty="0">
-                <a:solidFill>
-                  <a:schemeClr val="bg1"/>
-                </a:solidFill>
-              </a:rPr>
-              <a:t>「やっぱり価格かな」</a:t>
-            </a:r>
-            <a:endParaRPr lang="en-US" sz="1300" dirty="0"/>
-          </a:p>
-        </p:txBody>
-      </p:sp>
-      <p:sp>
-        <p:nvSpPr>
-          <p:cNvPr id="10" name="Customer circle"/>
-          <p:cNvSpPr/>
-          <p:nvPr/>
-        </p:nvSpPr>
-        <p:spPr>
-          <a:xfrm>
-            <a:off x="5440680" y="2171700"/>
-            <a:ext cx="502920" cy="502920"/>
-          </a:xfrm>
-          <a:prstGeom prst="ellipse">
-            <a:avLst/>
-          </a:prstGeom>
-          <a:solidFill>
-            <a:schemeClr val="accent3"/>
-          </a:solidFill>
-          <a:ln/>
-        </p:spPr>
-      </p:sp>
       <p:pic>
         <p:nvPicPr>
-          <p:cNvPr id="11" name="Customer icon" descr="Customer">    </p:cNvPr>
-          <p:cNvPicPr>
-            <a:picLocks noChangeAspect="1"/>
-          </p:cNvPicPr>
-          <p:nvPr/>
-        </p:nvPicPr>
-        <p:blipFill>
-          <a:blip r:embed="rId2"/>
-          <a:stretch>
-            <a:fillRect/>
-          </a:stretch>
-        </p:blipFill>
-        <p:spPr>
-          <a:xfrm>
-            <a:off x="5566410" y="2297430"/>
-            <a:ext cx="251460" cy="251460"/>
-          </a:xfrm>
-          <a:prstGeom prst="rect">
-            <a:avLst/>
-          </a:prstGeom>
-        </p:spPr>
-      </p:pic>
-      <p:sp>
-        <p:nvSpPr>
-          <p:cNvPr id="12" name="Sales circle"/>
-          <p:cNvSpPr/>
-          <p:nvPr/>
-        </p:nvSpPr>
-        <p:spPr>
-          <a:xfrm>
-            <a:off x="457200" y="2971800"/>
-            <a:ext cx="502920" cy="502920"/>
-          </a:xfrm>
-          <a:prstGeom prst="ellipse">
-            <a:avLst/>
-          </a:prstGeom>
-          <a:solidFill>
-            <a:schemeClr val="tx2"/>
-          </a:solidFill>
-          <a:ln/>
-        </p:spPr>
-      </p:sp>
-      <p:pic>
-        <p:nvPicPr>
-          <p:cNvPr id="13" name="Sales icon" descr="Sales">    </p:cNvPr>
+          <p:cNvPr id="15" name="Insight icon" descr="ひらめき">    </p:cNvPr>
           <p:cNvPicPr>
             <a:picLocks noChangeAspect="1"/>
           </p:cNvPicPr>
@@ -2425,8 +2506,8 @@
         </p:blipFill>
         <p:spPr>
           <a:xfrm>
-            <a:off x="582930" y="3097530"/>
-            <a:ext cx="251460" cy="251460"/>
+            <a:off x="6492240" y="1600200"/>
+            <a:ext cx="365760" cy="365760"/>
           </a:xfrm>
           <a:prstGeom prst="rect">
             <a:avLst/>
@@ -2435,43 +2516,14 @@
       </p:pic>
       <p:sp>
         <p:nvSpPr>
-          <p:cNvPr id="14" name="Question bubble"/>
-          <p:cNvSpPr/>
-          <p:nvPr/>
-        </p:nvSpPr>
-        <p:spPr>
-          <a:xfrm>
-            <a:off x="1097280" y="2971800"/>
-            <a:ext cx="4206240" cy="685800"/>
-          </a:xfrm>
-          <a:prstGeom prst="roundRect">
-            <a:avLst>
-              <a:gd name="adj" fmla="val 16000"/>
-            </a:avLst>
-          </a:prstGeom>
-          <a:solidFill>
-            <a:schemeClr val="bg2"/>
-          </a:solidFill>
-          <a:ln/>
-          <a:effectLst>
-            <a:outerShdw sx="100000" sy="100000" kx="0" ky="0" algn="bl" rotWithShape="0" blurRad="76200" dist="25400" dir="5400000">
-              <a:srgbClr val="000000">
-                <a:alpha val="12000"/>
-              </a:srgbClr>
-            </a:outerShdw>
-          </a:effectLst>
-        </p:spPr>
-      </p:sp>
-      <p:sp>
-        <p:nvSpPr>
-          <p:cNvPr id="15" name="Text 10"/>
+          <p:cNvPr id="16" name="Text 11"/>
           <p:cNvSpPr txBox="1"/>
           <p:nvPr/>
         </p:nvSpPr>
         <p:spPr>
           <a:xfrm>
-            <a:off x="1234440" y="2971800"/>
-            <a:ext cx="3931920" cy="685800"/>
+            <a:off x="6949440" y="1600200"/>
+            <a:ext cx="1554480" cy="365760"/>
           </a:xfrm>
           <a:prstGeom prst="rect">
             <a:avLst/>
@@ -2487,45 +2539,16 @@
               <a:buNone/>
             </a:pPr>
             <a:r>
-              <a:rPr lang="en-US" sz="1200" dirty="0">
-                <a:solidFill>
-                  <a:schemeClr val="tx1"/>
-                </a:solidFill>
-              </a:rPr>
-              <a:t>普段はお食事の際やお掃除など、どのような場面で使われることが多いですか？</a:t>
-            </a:r>
-            <a:endParaRPr lang="en-US" sz="1200" dirty="0"/>
-          </a:p>
-        </p:txBody>
-      </p:sp>
-      <p:sp>
-        <p:nvSpPr>
-          <p:cNvPr id="16" name="Answer bubble"/>
-          <p:cNvSpPr/>
-          <p:nvPr/>
-        </p:nvSpPr>
-        <p:spPr>
-          <a:xfrm>
-            <a:off x="1828800" y="3794760"/>
-            <a:ext cx="3474720" cy="457200"/>
-          </a:xfrm>
-          <a:prstGeom prst="roundRect">
-            <a:avLst>
-              <a:gd name="adj" fmla="val 24000"/>
-            </a:avLst>
-          </a:prstGeom>
-          <a:solidFill>
-            <a:schemeClr val="accent3"/>
-          </a:solidFill>
-          <a:ln/>
-          <a:effectLst>
-            <a:outerShdw sx="100000" sy="100000" kx="0" ky="0" algn="bl" rotWithShape="0" blurRad="76200" dist="25400" dir="5400000">
-              <a:srgbClr val="000000">
-                <a:alpha val="12000"/>
-              </a:srgbClr>
-            </a:outerShdw>
-          </a:effectLst>
-        </p:spPr>
+              <a:rPr lang="en-US" sz="1400" b="1" dirty="0">
+                <a:solidFill>
+                  <a:schemeClr val="bg1"/>
+                </a:solidFill>
+              </a:rPr>
+              <a:t>ご提案</a:t>
+            </a:r>
+            <a:endParaRPr lang="en-US" sz="1400" dirty="0"/>
+          </a:p>
+        </p:txBody>
       </p:sp>
       <p:sp>
         <p:nvSpPr>
@@ -2535,270 +2558,133 @@
         </p:nvSpPr>
         <p:spPr>
           <a:xfrm>
-            <a:off x="1920240" y="3794760"/>
-            <a:ext cx="3291840" cy="457200"/>
-          </a:xfrm>
-          <a:prstGeom prst="rect">
-            <a:avLst/>
-          </a:prstGeom>
-          <a:noFill/>
-          <a:ln/>
-        </p:spPr>
-        <p:txBody>
-          <a:bodyPr wrap="square" lIns="0" tIns="0" rIns="0" bIns="0" rtlCol="0" anchor="ctr"/>
+            <a:off x="6492240" y="2148840"/>
+            <a:ext cx="2011680" cy="822960"/>
+          </a:xfrm>
+          <a:prstGeom prst="rect">
+            <a:avLst/>
+          </a:prstGeom>
+          <a:noFill/>
+          <a:ln/>
+        </p:spPr>
+        <p:txBody>
+          <a:bodyPr wrap="square" lIns="0" tIns="0" rIns="0" bIns="0" rtlCol="0" anchor="t"/>
           <a:lstStyle/>
           <a:p>
             <a:pPr indent="0" marL="0">
               <a:buNone/>
             </a:pPr>
             <a:r>
+              <a:rPr lang="en-US" sz="1500" b="1" dirty="0">
+                <a:solidFill>
+                  <a:schemeClr val="accent4"/>
+                </a:solidFill>
+              </a:rPr>
+              <a:t>1種類に絞らず、</a:t>
+            </a:r>
+            <a:endParaRPr lang="en-US" sz="1500" dirty="0"/>
+          </a:p>
+          <a:p>
+            <a:pPr indent="0" marL="0">
+              <a:buNone/>
+            </a:pPr>
+            <a:r>
+              <a:rPr lang="en-US" sz="1500" b="1" dirty="0">
+                <a:solidFill>
+                  <a:schemeClr val="accent4"/>
+                </a:solidFill>
+              </a:rPr>
+              <a:t>場面ごとに使い分ける</a:t>
+            </a:r>
+            <a:endParaRPr lang="en-US" sz="1500" dirty="0"/>
+          </a:p>
+        </p:txBody>
+      </p:sp>
+      <p:sp>
+        <p:nvSpPr>
+          <p:cNvPr id="18" name="Text 13"/>
+          <p:cNvSpPr txBox="1"/>
+          <p:nvPr/>
+        </p:nvSpPr>
+        <p:spPr>
+          <a:xfrm>
+            <a:off x="6492240" y="3063240"/>
+            <a:ext cx="2011680" cy="1188720"/>
+          </a:xfrm>
+          <a:prstGeom prst="rect">
+            <a:avLst/>
+          </a:prstGeom>
+          <a:noFill/>
+          <a:ln/>
+        </p:spPr>
+        <p:txBody>
+          <a:bodyPr wrap="square" lIns="0" tIns="0" rIns="0" bIns="0" rtlCol="0" anchor="t"/>
+          <a:lstStyle/>
+          <a:p>
+            <a:pPr indent="0" marL="0">
+              <a:spcAft>
+                <a:spcPts val="200"/>
+              </a:spcAft>
+              <a:buNone/>
+            </a:pPr>
+            <a:r>
+              <a:rPr lang="en-US" sz="1100" dirty="0">
+                <a:solidFill>
+                  <a:schemeClr val="accent6"/>
+                </a:solidFill>
+              </a:rPr>
+              <a:t>普段使い</a:t>
+            </a:r>
+            <a:endParaRPr lang="en-US" sz="1300" dirty="0"/>
+          </a:p>
+          <a:p>
+            <a:pPr indent="0" marL="0">
+              <a:spcAft>
+                <a:spcPts val="200"/>
+              </a:spcAft>
+              <a:buNone/>
+            </a:pPr>
+            <a:r>
               <a:rPr lang="en-US" sz="1300" b="1" dirty="0">
                 <a:solidFill>
                   <a:schemeClr val="bg1"/>
                 </a:solidFill>
               </a:rPr>
-              <a:t>「食事のときとか、鼻をかむときかな」</a:t>
+              <a:t>→ 価格重視タイプ</a:t>
             </a:r>
             <a:endParaRPr lang="en-US" sz="1300" dirty="0"/>
           </a:p>
-        </p:txBody>
-      </p:sp>
-      <p:sp>
-        <p:nvSpPr>
-          <p:cNvPr id="18" name="Customer circle"/>
-          <p:cNvSpPr/>
-          <p:nvPr/>
-        </p:nvSpPr>
-        <p:spPr>
-          <a:xfrm>
-            <a:off x="5440680" y="3771900"/>
-            <a:ext cx="502920" cy="502920"/>
-          </a:xfrm>
-          <a:prstGeom prst="ellipse">
-            <a:avLst/>
-          </a:prstGeom>
-          <a:solidFill>
-            <a:schemeClr val="accent3"/>
-          </a:solidFill>
-          <a:ln/>
-        </p:spPr>
-      </p:sp>
-      <p:pic>
-        <p:nvPicPr>
-          <p:cNvPr id="19" name="Customer icon" descr="Customer">    </p:cNvPr>
-          <p:cNvPicPr>
-            <a:picLocks noChangeAspect="1"/>
-          </p:cNvPicPr>
-          <p:nvPr/>
-        </p:nvPicPr>
-        <p:blipFill>
-          <a:blip r:embed="rId4"/>
-          <a:stretch>
-            <a:fillRect/>
-          </a:stretch>
-        </p:blipFill>
-        <p:spPr>
-          <a:xfrm>
-            <a:off x="5566410" y="3897630"/>
-            <a:ext cx="251460" cy="251460"/>
-          </a:xfrm>
-          <a:prstGeom prst="rect">
-            <a:avLst/>
-          </a:prstGeom>
-        </p:spPr>
-      </p:pic>
-      <p:sp>
-        <p:nvSpPr>
-          <p:cNvPr id="20" name="Insight card"/>
-          <p:cNvSpPr/>
-          <p:nvPr/>
-        </p:nvSpPr>
-        <p:spPr>
-          <a:xfrm>
-            <a:off x="6309360" y="1371600"/>
-            <a:ext cx="2377440" cy="3108960"/>
-          </a:xfrm>
-          <a:prstGeom prst="roundRect">
-            <a:avLst>
-              <a:gd name="adj" fmla="val 4615"/>
-            </a:avLst>
-          </a:prstGeom>
-          <a:solidFill>
-            <a:schemeClr val="tx2"/>
-          </a:solidFill>
-          <a:ln/>
-          <a:effectLst>
-            <a:outerShdw sx="100000" sy="100000" kx="0" ky="0" algn="bl" rotWithShape="0" blurRad="76200" dist="25400" dir="5400000">
-              <a:srgbClr val="000000">
-                <a:alpha val="12000"/>
-              </a:srgbClr>
-            </a:outerShdw>
-          </a:effectLst>
-        </p:spPr>
-      </p:sp>
-      <p:pic>
-        <p:nvPicPr>
-          <p:cNvPr id="21" name="Insight icon" descr="ひらめき">    </p:cNvPr>
-          <p:cNvPicPr>
-            <a:picLocks noChangeAspect="1"/>
-          </p:cNvPicPr>
-          <p:nvPr/>
-        </p:nvPicPr>
-        <p:blipFill>
-          <a:blip r:embed="rId5"/>
-          <a:stretch>
-            <a:fillRect/>
-          </a:stretch>
-        </p:blipFill>
-        <p:spPr>
-          <a:xfrm>
-            <a:off x="6446520" y="1554480"/>
-            <a:ext cx="365760" cy="365760"/>
-          </a:xfrm>
-          <a:prstGeom prst="rect">
-            <a:avLst/>
-          </a:prstGeom>
-        </p:spPr>
-      </p:pic>
-      <p:sp>
-        <p:nvSpPr>
-          <p:cNvPr id="22" name="Text 15"/>
-          <p:cNvSpPr txBox="1"/>
-          <p:nvPr/>
-        </p:nvSpPr>
-        <p:spPr>
-          <a:xfrm>
-            <a:off x="6903720" y="1572768"/>
-            <a:ext cx="1645920" cy="365760"/>
-          </a:xfrm>
-          <a:prstGeom prst="rect">
-            <a:avLst/>
-          </a:prstGeom>
-          <a:noFill/>
-          <a:ln/>
-        </p:spPr>
-        <p:txBody>
-          <a:bodyPr wrap="square" lIns="0" tIns="0" rIns="0" bIns="0" rtlCol="0" anchor="ctr"/>
-          <a:lstStyle/>
           <a:p>
             <a:pPr indent="0" marL="0">
-              <a:buNone/>
-            </a:pPr>
-            <a:r>
-              <a:rPr lang="en-US" sz="1400" b="1" dirty="0">
+              <a:spcAft>
+                <a:spcPts val="200"/>
+              </a:spcAft>
+              <a:buNone/>
+            </a:pPr>
+            <a:r>
+              <a:rPr lang="en-US" sz="1100" dirty="0">
+                <a:solidFill>
+                  <a:schemeClr val="accent6"/>
+                </a:solidFill>
+              </a:rPr>
+              <a:t>鼻をかむとき</a:t>
+            </a:r>
+            <a:endParaRPr lang="en-US" sz="1300" dirty="0"/>
+          </a:p>
+          <a:p>
+            <a:pPr indent="0" marL="0">
+              <a:spcAft>
+                <a:spcPts val="200"/>
+              </a:spcAft>
+              <a:buNone/>
+            </a:pPr>
+            <a:r>
+              <a:rPr lang="en-US" sz="1300" b="1" dirty="0">
                 <a:solidFill>
                   <a:schemeClr val="bg1"/>
                 </a:solidFill>
               </a:rPr>
-              <a:t>見えたニーズ</a:t>
-            </a:r>
-            <a:endParaRPr lang="en-US" sz="1400" dirty="0"/>
-          </a:p>
-        </p:txBody>
-      </p:sp>
-      <p:sp>
-        <p:nvSpPr>
-          <p:cNvPr id="23" name="Text 16"/>
-          <p:cNvSpPr txBox="1"/>
-          <p:nvPr/>
-        </p:nvSpPr>
-        <p:spPr>
-          <a:xfrm>
-            <a:off x="6446520" y="2103120"/>
-            <a:ext cx="2103120" cy="1280160"/>
-          </a:xfrm>
-          <a:prstGeom prst="rect">
-            <a:avLst/>
-          </a:prstGeom>
-          <a:noFill/>
-          <a:ln/>
-        </p:spPr>
-        <p:txBody>
-          <a:bodyPr wrap="square" lIns="0" tIns="0" rIns="0" bIns="0" rtlCol="0" anchor="t"/>
-          <a:lstStyle/>
-          <a:p>
-            <a:pPr marL="342900" indent="-342900">
-              <a:spcAft>
-                <a:spcPts val="600"/>
-              </a:spcAft>
-              <a:buSzPct val="100000"/>
-              <a:buChar char="•"/>
-            </a:pPr>
-            <a:r>
-              <a:rPr lang="en-US" sz="1200" dirty="0">
-                <a:solidFill>
-                  <a:schemeClr val="bg1"/>
-                </a:solidFill>
-              </a:rPr>
-              <a:t>重視するのは「価格」</a:t>
-            </a:r>
-            <a:endParaRPr lang="en-US" sz="1200" dirty="0"/>
-          </a:p>
-          <a:p>
-            <a:pPr marL="342900" indent="-342900">
-              <a:spcAft>
-                <a:spcPts val="600"/>
-              </a:spcAft>
-              <a:buSzPct val="100000"/>
-              <a:buChar char="•"/>
-            </a:pPr>
-            <a:r>
-              <a:rPr lang="en-US" sz="1200" dirty="0">
-                <a:solidFill>
-                  <a:schemeClr val="bg1"/>
-                </a:solidFill>
-              </a:rPr>
-              <a:t>使う場面は「食事」と「鼻をかむとき」</a:t>
-            </a:r>
-            <a:endParaRPr lang="en-US" sz="1200" dirty="0"/>
-          </a:p>
-        </p:txBody>
-      </p:sp>
-      <p:sp>
-        <p:nvSpPr>
-          <p:cNvPr id="24" name="Text 17"/>
-          <p:cNvSpPr txBox="1"/>
-          <p:nvPr/>
-        </p:nvSpPr>
-        <p:spPr>
-          <a:xfrm>
-            <a:off x="6446520" y="3520440"/>
-            <a:ext cx="2103120" cy="731520"/>
-          </a:xfrm>
-          <a:prstGeom prst="rect">
-            <a:avLst/>
-          </a:prstGeom>
-          <a:noFill/>
-          <a:ln/>
-        </p:spPr>
-        <p:txBody>
-          <a:bodyPr wrap="square" lIns="0" tIns="0" rIns="0" bIns="0" rtlCol="0" anchor="t"/>
-          <a:lstStyle/>
-          <a:p>
-            <a:pPr indent="0" marL="0">
-              <a:buNone/>
-            </a:pPr>
-            <a:r>
-              <a:rPr lang="en-US" sz="1300" b="1" dirty="0">
-                <a:solidFill>
-                  <a:schemeClr val="accent4"/>
-                </a:solidFill>
-              </a:rPr>
-              <a:t>→ 場面ごとの</a:t>
-            </a:r>
-            <a:endParaRPr lang="en-US" sz="1300" dirty="0"/>
-          </a:p>
-          <a:p>
-            <a:pPr indent="0" marL="0">
-              <a:buNone/>
-            </a:pPr>
-            <a:r>
-              <a:rPr lang="en-US" sz="1300" b="1" dirty="0">
-                <a:solidFill>
-                  <a:schemeClr val="accent4"/>
-                </a:solidFill>
-              </a:rPr>
-              <a:t>「使い分け」をご提案</a:t>
+              <a:t>→ 高品質タイプ</a:t>
             </a:r>
             <a:endParaRPr lang="en-US" sz="1300" dirty="0"/>
           </a:p>
@@ -4212,7 +4098,7 @@
                   <a:schemeClr val="accent2"/>
                 </a:solidFill>
               </a:rPr>
-              <a:t>④ 比較・お客様に合わせたご提案</a:t>
+              <a:t>④ 2種類の使い分け</a:t>
             </a:r>
             <a:endParaRPr lang="en-US" sz="1200" dirty="0"/>
           </a:p>
@@ -4829,7 +4715,7 @@
                   <a:schemeClr val="accent2"/>
                 </a:solidFill>
               </a:rPr>
-              <a:t>⑤ クロージング</a:t>
+              <a:t>⑤ ご提案</a:t>
             </a:r>
             <a:endParaRPr lang="en-US" sz="1200" dirty="0"/>
           </a:p>

</xml_diff>

<commit_message>
Remove key points slide from tissue deck
Co-Authored-By: Claude Opus 5.5 <noreply@anthropic.com>
Claude-Session: https://claude.ai/code/session_01K1zKozKMB1GPwZUgJWygu6
</commit_message>
<xml_diff>
--- a/tissue_sales_roleplay.pptx
+++ b/tissue_sales_roleplay.pptx
@@ -12,10 +12,9 @@
     <p:sldId id="260" r:id="rId6"/>
     <p:sldId id="261" r:id="rId7"/>
     <p:sldId id="262" r:id="rId8"/>
-    <p:sldId id="263" r:id="rId9"/>
   </p:sldIdLst>
   <p:notesMasterIdLst>
-    <p:notesMasterId r:id="rId10"/>
+    <p:notesMasterId r:id="rId9"/>
   </p:notesMasterIdLst>
   <p:sldSz cx="9144000" cy="5143500"/>
   <p:notesSz cx="5143500" cy="9144000"/>
@@ -114,40 +113,35 @@
   <p:extLst>
     <p:ext uri="{521415D9-36F7-43E2-AB2F-B90AF26B5E84}">
       <p14:sectionLst xmlns:p14="http://schemas.microsoft.com/office/powerpoint/2010/main">
-        <p14:section name="導入" id="{efdb0549-c016-f8c4-f44d-24bc691fe559}">
+        <p14:section name="導入" id="{b34efa15-3c09-8ede-9c06-cc94ef689be0}">
           <p14:sldIdLst>
             <p14:sldId id="256"/>
           </p14:sldIdLst>
         </p14:section>
-        <p14:section name="ヒアリング" id="{b855579e-5d02-fc39-58f1-29e8154526bf}">
+        <p14:section name="ヒアリング" id="{5eb41ee8-69ff-689d-c97e-9fa6769b03cb}">
           <p14:sldIdLst>
             <p14:sldId id="257"/>
           </p14:sldIdLst>
         </p14:section>
-        <p14:section name="商品提案" id="{b4fb0f8e-0c4d-6bec-efda-9153714812f6}">
+        <p14:section name="商品提案" id="{db50b244-b166-eff8-f9e3-e04f8499dc57}">
           <p14:sldIdLst>
             <p14:sldId id="258"/>
             <p14:sldId id="259"/>
           </p14:sldIdLst>
         </p14:section>
-        <p14:section name="使い分け" id="{90bd8987-e554-68eb-9222-e75d436cc849}">
+        <p14:section name="使い分け" id="{3a69200e-e919-e829-16c1-5a19609a3dd3}">
           <p14:sldIdLst>
             <p14:sldId id="260"/>
           </p14:sldIdLst>
         </p14:section>
-        <p14:section name="クロージング" id="{6282efb0-a891-7b6f-2f2c-ebc46dcb2f1d}">
+        <p14:section name="クロージング" id="{0d5820fc-3538-1e14-453b-6ed3b474f07e}">
           <p14:sldIdLst>
             <p14:sldId id="261"/>
           </p14:sldIdLst>
         </p14:section>
-        <p14:section name="振り返り" id="{cedebb28-3dee-c8af-2197-f237513ac78c}">
+        <p14:section name="まとめ" id="{ab77a815-22ed-e6b4-bd2a-884398123636}">
           <p14:sldIdLst>
             <p14:sldId id="262"/>
-          </p14:sldIdLst>
-        </p14:section>
-        <p14:section name="まとめ" id="{3c7dff77-96ef-9c91-22c6-af972734d167}">
-          <p14:sldIdLst>
-            <p14:sldId id="263"/>
           </p14:sldIdLst>
         </p14:section>
       </p14:sectionLst>
@@ -1104,7 +1098,7 @@
           <a:p>
             <a:r>
               <a:rPr lang="en-US" dirty="0"/>
-              <a:t>このロールプレイでは、4つのことを意識しました。1つ目は、まずお客様のご希望と使う場面を伺うこと。2つ目は、お客様の気持ちに共感すること。3つ目は、どちらかを押し付けず、場面ごとの使い分けをご提案すること。4つ目は、1つずつのお試しで、購入のハードルを下げることです。</a:t>
+              <a:t>「私は営業において、商品の良さを一方的にお伝えするのではなく、お客様が何を大切にされているのかを伺い、その方に合った価値をご提案することを心がけています。」</a:t>
             </a:r>
             <a:endParaRPr lang="en-US" dirty="0"/>
           </a:p>
@@ -1128,94 +1122,6 @@
             <a:fld id="{F7021451-1387-4CA6-816F-3879F97B5CBC}" type="slidenum">
               <a:rPr lang="en-US"/>
               <a:t>7</a:t>
-            </a:fld>
-            <a:endParaRPr lang="en-US"/>
-          </a:p>
-        </p:txBody>
-      </p:sp>
-    </p:spTree>
-    <p:extLst>
-      <p:ext uri="{BB962C8B-B14F-4D97-AF65-F5344CB8AC3E}">
-        <p14:creationId xmlns:p14="http://schemas.microsoft.com/office/powerpoint/2010/main" val="1024086991"/>
-      </p:ext>
-    </p:extLst>
-  </p:cSld>
-  <p:clrMapOvr>
-    <a:masterClrMapping/>
-  </p:clrMapOvr>
-</p:notes>
-</file>
-
-<file path=ppt/notesSlides/notesSlide8.xml><?xml version="1.0" encoding="utf-8"?>
-<p:notes xmlns:a="http://schemas.openxmlformats.org/drawingml/2006/main" xmlns:r="http://schemas.openxmlformats.org/officeDocument/2006/relationships" xmlns:p="http://schemas.openxmlformats.org/presentationml/2006/main">
-  <p:cSld>
-    <p:spTree>
-      <p:nvGrpSpPr>
-        <p:cNvPr id="1" name=""/>
-        <p:cNvGrpSpPr/>
-        <p:nvPr/>
-      </p:nvGrpSpPr>
-      <p:grpSpPr>
-        <a:xfrm>
-          <a:off x="0" y="0"/>
-          <a:ext cx="0" cy="0"/>
-          <a:chOff x="0" y="0"/>
-          <a:chExt cx="0" cy="0"/>
-        </a:xfrm>
-      </p:grpSpPr>
-      <p:sp>
-        <p:nvSpPr>
-          <p:cNvPr id="2" name="Slide Image Placeholder 1"/>
-          <p:cNvSpPr>
-            <a:spLocks noGrp="1" noRot="1" noChangeAspect="1"/>
-          </p:cNvSpPr>
-          <p:nvPr>
-            <p:ph type="sldImg"/>
-          </p:nvPr>
-        </p:nvSpPr>
-        <p:spPr/>
-      </p:sp>
-      <p:sp>
-        <p:nvSpPr>
-          <p:cNvPr id="3" name="Notes Placeholder 2"/>
-          <p:cNvSpPr>
-            <a:spLocks noGrp="1"/>
-          </p:cNvSpPr>
-          <p:nvPr>
-            <p:ph type="body" idx="1"/>
-          </p:nvPr>
-        </p:nvSpPr>
-        <p:spPr/>
-        <p:txBody>
-          <a:bodyPr/>
-          <a:lstStyle/>
-          <a:p>
-            <a:r>
-              <a:rPr lang="en-US" dirty="0"/>
-              <a:t>「私は営業において、商品の良さを一方的にお伝えするのではなく、お客様が何を大切にされているのかを伺い、その方に合った価値をご提案することを心がけています。」</a:t>
-            </a:r>
-            <a:endParaRPr lang="en-US" dirty="0"/>
-          </a:p>
-        </p:txBody>
-      </p:sp>
-      <p:sp>
-        <p:nvSpPr>
-          <p:cNvPr id="4" name="Slide Number Placeholder 3"/>
-          <p:cNvSpPr>
-            <a:spLocks noGrp="1"/>
-          </p:cNvSpPr>
-          <p:nvPr>
-            <p:ph type="sldNum" sz="quarter" idx="10"/>
-          </p:nvPr>
-        </p:nvSpPr>
-        <p:spPr/>
-        <p:txBody>
-          <a:bodyPr/>
-          <a:lstStyle/>
-          <a:p>
-            <a:fld id="{F7021451-1387-4CA6-816F-3879F97B5CBC}" type="slidenum">
-              <a:rPr lang="en-US"/>
-              <a:t>8</a:t>
             </a:fld>
             <a:endParaRPr lang="en-US"/>
           </a:p>
@@ -5125,732 +5031,6 @@
 <file path=ppt/slides/slide7.xml><?xml version="1.0" encoding="utf-8"?>
 <p:sld xmlns:a="http://schemas.openxmlformats.org/drawingml/2006/main" xmlns:r="http://schemas.openxmlformats.org/officeDocument/2006/relationships" xmlns:p="http://schemas.openxmlformats.org/presentationml/2006/main">
   <p:cSld name="Slide 7">
-    <p:spTree>
-      <p:nvGrpSpPr>
-        <p:cNvPr id="1" name=""/>
-        <p:cNvGrpSpPr/>
-        <p:nvPr/>
-      </p:nvGrpSpPr>
-      <p:grpSpPr>
-        <a:xfrm>
-          <a:off x="0" y="0"/>
-          <a:ext cx="0" cy="0"/>
-          <a:chOff x="0" y="0"/>
-          <a:chExt cx="0" cy="0"/>
-        </a:xfrm>
-      </p:grpSpPr>
-      <p:sp>
-        <p:nvSpPr>
-          <p:cNvPr id="2" name="Text 0"/>
-          <p:cNvSpPr/>
-          <p:nvPr>
-            <p:ph idx="100" type="body" hasCustomPrompt="1"/>
-          </p:nvPr>
-        </p:nvSpPr>
-        <p:spPr>
-          <a:xfrm>
-            <a:off x="457200" y="274320"/>
-            <a:ext cx="5486400" cy="274320"/>
-          </a:xfrm>
-          <a:prstGeom prst="rect">
-            <a:avLst/>
-          </a:prstGeom>
-          <a:noFill/>
-          <a:ln/>
-        </p:spPr>
-        <p:txBody>
-          <a:bodyPr wrap="square" lIns="0" tIns="0" rIns="0" bIns="0" rtlCol="0"/>
-          <a:lstStyle/>
-          <a:p>
-            <a:pPr algn="l" indent="0" marL="0">
-              <a:buNone/>
-            </a:pPr>
-            <a:r>
-              <a:rPr lang="en-US" sz="1200" b="1" dirty="0">
-                <a:solidFill>
-                  <a:schemeClr val="accent2"/>
-                </a:solidFill>
-              </a:rPr>
-              <a:t>POINTS</a:t>
-            </a:r>
-            <a:endParaRPr lang="en-US" sz="1200" dirty="0"/>
-          </a:p>
-        </p:txBody>
-      </p:sp>
-      <p:sp>
-        <p:nvSpPr>
-          <p:cNvPr id="3" name="Text 0"/>
-          <p:cNvSpPr/>
-          <p:nvPr>
-            <p:ph idx="101" type="title" hasCustomPrompt="1"/>
-          </p:nvPr>
-        </p:nvSpPr>
-        <p:spPr>
-          <a:xfrm>
-            <a:off x="457200" y="548640"/>
-            <a:ext cx="8229600" cy="548640"/>
-          </a:xfrm>
-          <a:prstGeom prst="rect">
-            <a:avLst/>
-          </a:prstGeom>
-          <a:noFill/>
-          <a:ln/>
-        </p:spPr>
-        <p:txBody>
-          <a:bodyPr wrap="square" lIns="0" tIns="0" rIns="0" bIns="0" rtlCol="0" anchor="ctr"/>
-          <a:lstStyle/>
-          <a:p>
-            <a:pPr algn="l" indent="0" marL="0">
-              <a:buNone/>
-            </a:pPr>
-            <a:r>
-              <a:rPr lang="en-US" sz="2600" b="1" dirty="0">
-                <a:solidFill>
-                  <a:schemeClr val="tx2"/>
-                </a:solidFill>
-              </a:rPr>
-              <a:t>この提案で意識したポイント</a:t>
-            </a:r>
-            <a:endParaRPr lang="en-US" sz="2600" dirty="0"/>
-          </a:p>
-        </p:txBody>
-      </p:sp>
-      <p:sp>
-        <p:nvSpPr>
-          <p:cNvPr id="4" name="Point card"/>
-          <p:cNvSpPr/>
-          <p:nvPr/>
-        </p:nvSpPr>
-        <p:spPr>
-          <a:xfrm>
-            <a:off x="457200" y="1371600"/>
-            <a:ext cx="4023360" cy="1371600"/>
-          </a:xfrm>
-          <a:prstGeom prst="roundRect">
-            <a:avLst>
-              <a:gd name="adj" fmla="val 8000"/>
-            </a:avLst>
-          </a:prstGeom>
-          <a:solidFill>
-            <a:schemeClr val="bg2"/>
-          </a:solidFill>
-          <a:ln/>
-          <a:effectLst>
-            <a:outerShdw sx="100000" sy="100000" kx="0" ky="0" algn="bl" rotWithShape="0" blurRad="76200" dist="25400" dir="5400000">
-              <a:srgbClr val="000000">
-                <a:alpha val="12000"/>
-              </a:srgbClr>
-            </a:outerShdw>
-          </a:effectLst>
-        </p:spPr>
-      </p:sp>
-      <p:sp>
-        <p:nvSpPr>
-          <p:cNvPr id="5" name="まず伺う circle"/>
-          <p:cNvSpPr/>
-          <p:nvPr/>
-        </p:nvSpPr>
-        <p:spPr>
-          <a:xfrm>
-            <a:off x="685800" y="1645920"/>
-            <a:ext cx="822960" cy="822960"/>
-          </a:xfrm>
-          <a:prstGeom prst="ellipse">
-            <a:avLst/>
-          </a:prstGeom>
-          <a:solidFill>
-            <a:schemeClr val="tx2"/>
-          </a:solidFill>
-          <a:ln/>
-        </p:spPr>
-      </p:sp>
-      <p:pic>
-        <p:nvPicPr>
-          <p:cNvPr id="6" name="まず伺う icon" descr="まず伺う">    </p:cNvPr>
-          <p:cNvPicPr>
-            <a:picLocks noChangeAspect="1"/>
-          </p:cNvPicPr>
-          <p:nvPr/>
-        </p:nvPicPr>
-        <p:blipFill>
-          <a:blip r:embed="rId1"/>
-          <a:stretch>
-            <a:fillRect/>
-          </a:stretch>
-        </p:blipFill>
-        <p:spPr>
-          <a:xfrm>
-            <a:off x="891540" y="1851660"/>
-            <a:ext cx="411480" cy="411480"/>
-          </a:xfrm>
-          <a:prstGeom prst="rect">
-            <a:avLst/>
-          </a:prstGeom>
-        </p:spPr>
-      </p:pic>
-      <p:sp>
-        <p:nvSpPr>
-          <p:cNvPr id="7" name="Text 4"/>
-          <p:cNvSpPr txBox="1"/>
-          <p:nvPr/>
-        </p:nvSpPr>
-        <p:spPr>
-          <a:xfrm>
-            <a:off x="1737360" y="1600200"/>
-            <a:ext cx="2560320" cy="365760"/>
-          </a:xfrm>
-          <a:prstGeom prst="rect">
-            <a:avLst/>
-          </a:prstGeom>
-          <a:noFill/>
-          <a:ln/>
-        </p:spPr>
-        <p:txBody>
-          <a:bodyPr wrap="square" lIns="0" tIns="0" rIns="0" bIns="0" rtlCol="0" anchor="t"/>
-          <a:lstStyle/>
-          <a:p>
-            <a:pPr indent="0" marL="0">
-              <a:buNone/>
-            </a:pPr>
-            <a:r>
-              <a:rPr lang="en-US" sz="1600" b="1" dirty="0">
-                <a:solidFill>
-                  <a:schemeClr val="tx2"/>
-                </a:solidFill>
-              </a:rPr>
-              <a:t>1. まず伺う</a:t>
-            </a:r>
-            <a:endParaRPr lang="en-US" sz="1600" dirty="0"/>
-          </a:p>
-        </p:txBody>
-      </p:sp>
-      <p:sp>
-        <p:nvSpPr>
-          <p:cNvPr id="8" name="Text 5"/>
-          <p:cNvSpPr txBox="1"/>
-          <p:nvPr/>
-        </p:nvSpPr>
-        <p:spPr>
-          <a:xfrm>
-            <a:off x="1737360" y="2011680"/>
-            <a:ext cx="2560320" cy="640080"/>
-          </a:xfrm>
-          <a:prstGeom prst="rect">
-            <a:avLst/>
-          </a:prstGeom>
-          <a:noFill/>
-          <a:ln/>
-        </p:spPr>
-        <p:txBody>
-          <a:bodyPr wrap="square" lIns="0" tIns="0" rIns="0" bIns="0" rtlCol="0" anchor="t"/>
-          <a:lstStyle/>
-          <a:p>
-            <a:pPr indent="0" marL="0">
-              <a:buNone/>
-            </a:pPr>
-            <a:r>
-              <a:rPr lang="en-US" sz="1200" dirty="0">
-                <a:solidFill>
-                  <a:schemeClr val="tx1"/>
-                </a:solidFill>
-              </a:rPr>
-              <a:t>価格と使い心地のどちらを重視するか、どんな場面で使うかを質問</a:t>
-            </a:r>
-            <a:endParaRPr lang="en-US" sz="1200" dirty="0"/>
-          </a:p>
-        </p:txBody>
-      </p:sp>
-      <p:sp>
-        <p:nvSpPr>
-          <p:cNvPr id="9" name="Point card"/>
-          <p:cNvSpPr/>
-          <p:nvPr/>
-        </p:nvSpPr>
-        <p:spPr>
-          <a:xfrm>
-            <a:off x="4663440" y="1371600"/>
-            <a:ext cx="4023360" cy="1371600"/>
-          </a:xfrm>
-          <a:prstGeom prst="roundRect">
-            <a:avLst>
-              <a:gd name="adj" fmla="val 8000"/>
-            </a:avLst>
-          </a:prstGeom>
-          <a:solidFill>
-            <a:schemeClr val="bg2"/>
-          </a:solidFill>
-          <a:ln/>
-          <a:effectLst>
-            <a:outerShdw sx="100000" sy="100000" kx="0" ky="0" algn="bl" rotWithShape="0" blurRad="76200" dist="25400" dir="5400000">
-              <a:srgbClr val="000000">
-                <a:alpha val="12000"/>
-              </a:srgbClr>
-            </a:outerShdw>
-          </a:effectLst>
-        </p:spPr>
-      </p:sp>
-      <p:sp>
-        <p:nvSpPr>
-          <p:cNvPr id="10" name="共感する circle"/>
-          <p:cNvSpPr/>
-          <p:nvPr/>
-        </p:nvSpPr>
-        <p:spPr>
-          <a:xfrm>
-            <a:off x="4892040" y="1645920"/>
-            <a:ext cx="822960" cy="822960"/>
-          </a:xfrm>
-          <a:prstGeom prst="ellipse">
-            <a:avLst/>
-          </a:prstGeom>
-          <a:solidFill>
-            <a:schemeClr val="accent3"/>
-          </a:solidFill>
-          <a:ln/>
-        </p:spPr>
-      </p:sp>
-      <p:pic>
-        <p:nvPicPr>
-          <p:cNvPr id="11" name="共感する icon" descr="共感する">    </p:cNvPr>
-          <p:cNvPicPr>
-            <a:picLocks noChangeAspect="1"/>
-          </p:cNvPicPr>
-          <p:nvPr/>
-        </p:nvPicPr>
-        <p:blipFill>
-          <a:blip r:embed="rId2"/>
-          <a:stretch>
-            <a:fillRect/>
-          </a:stretch>
-        </p:blipFill>
-        <p:spPr>
-          <a:xfrm>
-            <a:off x="5097780" y="1851660"/>
-            <a:ext cx="411480" cy="411480"/>
-          </a:xfrm>
-          <a:prstGeom prst="rect">
-            <a:avLst/>
-          </a:prstGeom>
-        </p:spPr>
-      </p:pic>
-      <p:sp>
-        <p:nvSpPr>
-          <p:cNvPr id="12" name="Text 8"/>
-          <p:cNvSpPr txBox="1"/>
-          <p:nvPr/>
-        </p:nvSpPr>
-        <p:spPr>
-          <a:xfrm>
-            <a:off x="5943600" y="1600200"/>
-            <a:ext cx="2560320" cy="365760"/>
-          </a:xfrm>
-          <a:prstGeom prst="rect">
-            <a:avLst/>
-          </a:prstGeom>
-          <a:noFill/>
-          <a:ln/>
-        </p:spPr>
-        <p:txBody>
-          <a:bodyPr wrap="square" lIns="0" tIns="0" rIns="0" bIns="0" rtlCol="0" anchor="t"/>
-          <a:lstStyle/>
-          <a:p>
-            <a:pPr indent="0" marL="0">
-              <a:buNone/>
-            </a:pPr>
-            <a:r>
-              <a:rPr lang="en-US" sz="1600" b="1" dirty="0">
-                <a:solidFill>
-                  <a:schemeClr val="tx2"/>
-                </a:solidFill>
-              </a:rPr>
-              <a:t>2. 共感する</a:t>
-            </a:r>
-            <a:endParaRPr lang="en-US" sz="1600" dirty="0"/>
-          </a:p>
-        </p:txBody>
-      </p:sp>
-      <p:sp>
-        <p:nvSpPr>
-          <p:cNvPr id="13" name="Text 9"/>
-          <p:cNvSpPr txBox="1"/>
-          <p:nvPr/>
-        </p:nvSpPr>
-        <p:spPr>
-          <a:xfrm>
-            <a:off x="5943600" y="2011680"/>
-            <a:ext cx="2560320" cy="640080"/>
-          </a:xfrm>
-          <a:prstGeom prst="rect">
-            <a:avLst/>
-          </a:prstGeom>
-          <a:noFill/>
-          <a:ln/>
-        </p:spPr>
-        <p:txBody>
-          <a:bodyPr wrap="square" lIns="0" tIns="0" rIns="0" bIns="0" rtlCol="0" anchor="t"/>
-          <a:lstStyle/>
-          <a:p>
-            <a:pPr indent="0" marL="0">
-              <a:buNone/>
-            </a:pPr>
-            <a:r>
-              <a:rPr lang="en-US" sz="1200" dirty="0">
-                <a:solidFill>
-                  <a:schemeClr val="tx1"/>
-                </a:solidFill>
-              </a:rPr>
-              <a:t>「費用を抑えたいですよね」「ヒリヒリした経験は？」と気持ちに寄り添う</a:t>
-            </a:r>
-            <a:endParaRPr lang="en-US" sz="1200" dirty="0"/>
-          </a:p>
-        </p:txBody>
-      </p:sp>
-      <p:sp>
-        <p:nvSpPr>
-          <p:cNvPr id="14" name="Point card"/>
-          <p:cNvSpPr/>
-          <p:nvPr/>
-        </p:nvSpPr>
-        <p:spPr>
-          <a:xfrm>
-            <a:off x="457200" y="2971800"/>
-            <a:ext cx="4023360" cy="1371600"/>
-          </a:xfrm>
-          <a:prstGeom prst="roundRect">
-            <a:avLst>
-              <a:gd name="adj" fmla="val 8000"/>
-            </a:avLst>
-          </a:prstGeom>
-          <a:solidFill>
-            <a:schemeClr val="bg2"/>
-          </a:solidFill>
-          <a:ln/>
-          <a:effectLst>
-            <a:outerShdw sx="100000" sy="100000" kx="0" ky="0" algn="bl" rotWithShape="0" blurRad="76200" dist="25400" dir="5400000">
-              <a:srgbClr val="000000">
-                <a:alpha val="12000"/>
-              </a:srgbClr>
-            </a:outerShdw>
-          </a:effectLst>
-        </p:spPr>
-      </p:sp>
-      <p:sp>
-        <p:nvSpPr>
-          <p:cNvPr id="15" name="押し付けない circle"/>
-          <p:cNvSpPr/>
-          <p:nvPr/>
-        </p:nvSpPr>
-        <p:spPr>
-          <a:xfrm>
-            <a:off x="685800" y="3246120"/>
-            <a:ext cx="822960" cy="822960"/>
-          </a:xfrm>
-          <a:prstGeom prst="ellipse">
-            <a:avLst/>
-          </a:prstGeom>
-          <a:solidFill>
-            <a:schemeClr val="accent2"/>
-          </a:solidFill>
-          <a:ln/>
-        </p:spPr>
-      </p:sp>
-      <p:pic>
-        <p:nvPicPr>
-          <p:cNvPr id="16" name="押し付けない icon" descr="押し付けない">    </p:cNvPr>
-          <p:cNvPicPr>
-            <a:picLocks noChangeAspect="1"/>
-          </p:cNvPicPr>
-          <p:nvPr/>
-        </p:nvPicPr>
-        <p:blipFill>
-          <a:blip r:embed="rId3"/>
-          <a:stretch>
-            <a:fillRect/>
-          </a:stretch>
-        </p:blipFill>
-        <p:spPr>
-          <a:xfrm>
-            <a:off x="891540" y="3451860"/>
-            <a:ext cx="411480" cy="411480"/>
-          </a:xfrm>
-          <a:prstGeom prst="rect">
-            <a:avLst/>
-          </a:prstGeom>
-        </p:spPr>
-      </p:pic>
-      <p:sp>
-        <p:nvSpPr>
-          <p:cNvPr id="17" name="Text 12"/>
-          <p:cNvSpPr txBox="1"/>
-          <p:nvPr/>
-        </p:nvSpPr>
-        <p:spPr>
-          <a:xfrm>
-            <a:off x="1737360" y="3200400"/>
-            <a:ext cx="2560320" cy="365760"/>
-          </a:xfrm>
-          <a:prstGeom prst="rect">
-            <a:avLst/>
-          </a:prstGeom>
-          <a:noFill/>
-          <a:ln/>
-        </p:spPr>
-        <p:txBody>
-          <a:bodyPr wrap="square" lIns="0" tIns="0" rIns="0" bIns="0" rtlCol="0" anchor="t"/>
-          <a:lstStyle/>
-          <a:p>
-            <a:pPr indent="0" marL="0">
-              <a:buNone/>
-            </a:pPr>
-            <a:r>
-              <a:rPr lang="en-US" sz="1600" b="1" dirty="0">
-                <a:solidFill>
-                  <a:schemeClr val="tx2"/>
-                </a:solidFill>
-              </a:rPr>
-              <a:t>3. 押し付けない</a:t>
-            </a:r>
-            <a:endParaRPr lang="en-US" sz="1600" dirty="0"/>
-          </a:p>
-        </p:txBody>
-      </p:sp>
-      <p:sp>
-        <p:nvSpPr>
-          <p:cNvPr id="18" name="Text 13"/>
-          <p:cNvSpPr txBox="1"/>
-          <p:nvPr/>
-        </p:nvSpPr>
-        <p:spPr>
-          <a:xfrm>
-            <a:off x="1737360" y="3611880"/>
-            <a:ext cx="2560320" cy="640080"/>
-          </a:xfrm>
-          <a:prstGeom prst="rect">
-            <a:avLst/>
-          </a:prstGeom>
-          <a:noFill/>
-          <a:ln/>
-        </p:spPr>
-        <p:txBody>
-          <a:bodyPr wrap="square" lIns="0" tIns="0" rIns="0" bIns="0" rtlCol="0" anchor="t"/>
-          <a:lstStyle/>
-          <a:p>
-            <a:pPr indent="0" marL="0">
-              <a:buNone/>
-            </a:pPr>
-            <a:r>
-              <a:rPr lang="en-US" sz="1200" dirty="0">
-                <a:solidFill>
-                  <a:schemeClr val="tx1"/>
-                </a:solidFill>
-              </a:rPr>
-              <a:t>どちらが良いかではなく、場面ごとの使い分けを提案</a:t>
-            </a:r>
-            <a:endParaRPr lang="en-US" sz="1200" dirty="0"/>
-          </a:p>
-        </p:txBody>
-      </p:sp>
-      <p:sp>
-        <p:nvSpPr>
-          <p:cNvPr id="19" name="Point card"/>
-          <p:cNvSpPr/>
-          <p:nvPr/>
-        </p:nvSpPr>
-        <p:spPr>
-          <a:xfrm>
-            <a:off x="4663440" y="2971800"/>
-            <a:ext cx="4023360" cy="1371600"/>
-          </a:xfrm>
-          <a:prstGeom prst="roundRect">
-            <a:avLst>
-              <a:gd name="adj" fmla="val 8000"/>
-            </a:avLst>
-          </a:prstGeom>
-          <a:solidFill>
-            <a:schemeClr val="bg2"/>
-          </a:solidFill>
-          <a:ln/>
-          <a:effectLst>
-            <a:outerShdw sx="100000" sy="100000" kx="0" ky="0" algn="bl" rotWithShape="0" blurRad="76200" dist="25400" dir="5400000">
-              <a:srgbClr val="000000">
-                <a:alpha val="12000"/>
-              </a:srgbClr>
-            </a:outerShdw>
-          </a:effectLst>
-        </p:spPr>
-      </p:sp>
-      <p:sp>
-        <p:nvSpPr>
-          <p:cNvPr id="20" name="小さく始める circle"/>
-          <p:cNvSpPr/>
-          <p:nvPr/>
-        </p:nvSpPr>
-        <p:spPr>
-          <a:xfrm>
-            <a:off x="4892040" y="3246120"/>
-            <a:ext cx="822960" cy="822960"/>
-          </a:xfrm>
-          <a:prstGeom prst="ellipse">
-            <a:avLst/>
-          </a:prstGeom>
-          <a:solidFill>
-            <a:schemeClr val="tx2"/>
-          </a:solidFill>
-          <a:ln/>
-        </p:spPr>
-      </p:sp>
-      <p:pic>
-        <p:nvPicPr>
-          <p:cNvPr id="21" name="小さく始める icon" descr="小さく始める">    </p:cNvPr>
-          <p:cNvPicPr>
-            <a:picLocks noChangeAspect="1"/>
-          </p:cNvPicPr>
-          <p:nvPr/>
-        </p:nvPicPr>
-        <p:blipFill>
-          <a:blip r:embed="rId4"/>
-          <a:stretch>
-            <a:fillRect/>
-          </a:stretch>
-        </p:blipFill>
-        <p:spPr>
-          <a:xfrm>
-            <a:off x="5097780" y="3451860"/>
-            <a:ext cx="411480" cy="411480"/>
-          </a:xfrm>
-          <a:prstGeom prst="rect">
-            <a:avLst/>
-          </a:prstGeom>
-        </p:spPr>
-      </p:pic>
-      <p:sp>
-        <p:nvSpPr>
-          <p:cNvPr id="22" name="Text 16"/>
-          <p:cNvSpPr txBox="1"/>
-          <p:nvPr/>
-        </p:nvSpPr>
-        <p:spPr>
-          <a:xfrm>
-            <a:off x="5943600" y="3200400"/>
-            <a:ext cx="2560320" cy="365760"/>
-          </a:xfrm>
-          <a:prstGeom prst="rect">
-            <a:avLst/>
-          </a:prstGeom>
-          <a:noFill/>
-          <a:ln/>
-        </p:spPr>
-        <p:txBody>
-          <a:bodyPr wrap="square" lIns="0" tIns="0" rIns="0" bIns="0" rtlCol="0" anchor="t"/>
-          <a:lstStyle/>
-          <a:p>
-            <a:pPr indent="0" marL="0">
-              <a:buNone/>
-            </a:pPr>
-            <a:r>
-              <a:rPr lang="en-US" sz="1600" b="1" dirty="0">
-                <a:solidFill>
-                  <a:schemeClr val="tx2"/>
-                </a:solidFill>
-              </a:rPr>
-              <a:t>4. 小さく始める</a:t>
-            </a:r>
-            <a:endParaRPr lang="en-US" sz="1600" dirty="0"/>
-          </a:p>
-        </p:txBody>
-      </p:sp>
-      <p:sp>
-        <p:nvSpPr>
-          <p:cNvPr id="23" name="Text 17"/>
-          <p:cNvSpPr txBox="1"/>
-          <p:nvPr/>
-        </p:nvSpPr>
-        <p:spPr>
-          <a:xfrm>
-            <a:off x="5943600" y="3611880"/>
-            <a:ext cx="2560320" cy="640080"/>
-          </a:xfrm>
-          <a:prstGeom prst="rect">
-            <a:avLst/>
-          </a:prstGeom>
-          <a:noFill/>
-          <a:ln/>
-        </p:spPr>
-        <p:txBody>
-          <a:bodyPr wrap="square" lIns="0" tIns="0" rIns="0" bIns="0" rtlCol="0" anchor="t"/>
-          <a:lstStyle/>
-          <a:p>
-            <a:pPr indent="0" marL="0">
-              <a:buNone/>
-            </a:pPr>
-            <a:r>
-              <a:rPr lang="en-US" sz="1200" dirty="0">
-                <a:solidFill>
-                  <a:schemeClr val="tx1"/>
-                </a:solidFill>
-              </a:rPr>
-              <a:t>まずは1つずつのお試しで、購入のハードルを下げる</a:t>
-            </a:r>
-            <a:endParaRPr lang="en-US" sz="1200" dirty="0"/>
-          </a:p>
-        </p:txBody>
-      </p:sp>
-      <p:sp>
-        <p:nvSpPr>
-          <p:cNvPr id="25" name="Slide Number Placeholder 0"/>
-          <p:cNvSpPr>
-            <a:spLocks noGrp="1"/>
-          </p:cNvSpPr>
-          <p:nvPr>
-            <p:ph type="sldNum" sz="quarter" idx="4294967295"/>
-          </p:nvPr>
-        </p:nvSpPr>
-        <p:spPr>
-          <a:xfrm>
-            <a:off x="8412480" y="4754880"/>
-            <a:ext cx="365760" cy="228600"/>
-          </a:xfrm>
-          <a:prstGeom prst="rect">
-            <a:avLst/>
-          </a:prstGeom>
-          <a:extLst>
-            <a:ext uri="{C572A759-6A51-4108-AA02-DFA0A04FC94B}">
-              <ma14:wrappingTextBoxFlag xmlns:ma14="http://schemas.microsoft.com/office/mac/drawingml/2011/main" val="0"/>
-            </a:ext>
-          </a:extLst>
-        </p:spPr>
-        <p:txBody>
-          <a:bodyPr/>
-          <a:lstStyle>
-            <a:lvl1pPr>
-              <a:defRPr sz="1000">
-                <a:solidFill>
-                  <a:schemeClr val="accent5"/>
-                </a:solidFill>
-              </a:defRPr>
-            </a:lvl1pPr>
-          </a:lstStyle>
-          <a:p>
-            <a:pPr algn="r"/>
-            <a:fld id="{F7021451-1387-4CA6-816F-3879F97B5CBC}" type="slidenum">
-              <a:rPr b="0" lang="en-US"/>
-              <a:t>7</a:t>
-            </a:fld>
-            <a:endParaRPr lang="en-US"/>
-          </a:p>
-        </p:txBody>
-      </p:sp>
-    </p:spTree>
-  </p:cSld>
-  <p:clrMapOvr>
-    <a:masterClrMapping/>
-  </p:clrMapOvr>
-</p:sld>
-</file>
-
-<file path=ppt/slides/slide8.xml><?xml version="1.0" encoding="utf-8"?>
-<p:sld xmlns:a="http://schemas.openxmlformats.org/drawingml/2006/main" xmlns:r="http://schemas.openxmlformats.org/officeDocument/2006/relationships" xmlns:p="http://schemas.openxmlformats.org/presentationml/2006/main">
-  <p:cSld name="Slide 8">
     <p:spTree>
       <p:nvGrpSpPr>
         <p:cNvPr id="1" name=""/>

</xml_diff>

<commit_message>
Rework tissue deck for office supplies B2B pitch
Retarget slides to corporate general affairs buyers: current-state
check, two product types for office use, usage split and trial rollout.

Co-Authored-By: Claude Opus 5.5 <noreply@anthropic.com>
Claude-Session: https://claude.ai/code/session_01K1zKozKMB1GPwZUgJWygu6
</commit_message>
<xml_diff>
--- a/tissue_sales_roleplay.pptx
+++ b/tissue_sales_roleplay.pptx
@@ -113,33 +113,29 @@
   <p:extLst>
     <p:ext uri="{521415D9-36F7-43E2-AB2F-B90AF26B5E84}">
       <p14:sectionLst xmlns:p14="http://schemas.microsoft.com/office/powerpoint/2010/main">
-        <p14:section name="導入" id="{b34efa15-3c09-8ede-9c06-cc94ef689be0}">
+        <p14:section name="ご挨拶" id="{51a8644e-4c1e-2115-fb43-16505fe58949}">
           <p14:sldIdLst>
             <p14:sldId id="256"/>
           </p14:sldIdLst>
         </p14:section>
-        <p14:section name="ヒアリング" id="{5eb41ee8-69ff-689d-c97e-9fa6769b03cb}">
+        <p14:section name="現状の確認" id="{73d5fc0b-a8fc-0073-fb52-bd01b0c4f229}">
           <p14:sldIdLst>
             <p14:sldId id="257"/>
           </p14:sldIdLst>
         </p14:section>
-        <p14:section name="商品提案" id="{db50b244-b166-eff8-f9e3-e04f8499dc57}">
+        <p14:section name="商品のご紹介" id="{d4ce7b63-bc76-78ae-c5ad-a331e4f442f0}">
           <p14:sldIdLst>
             <p14:sldId id="258"/>
             <p14:sldId id="259"/>
           </p14:sldIdLst>
         </p14:section>
-        <p14:section name="使い分け" id="{3a69200e-e919-e829-16c1-5a19609a3dd3}">
+        <p14:section name="ご提案" id="{03f744cd-445c-7a6f-ca54-f8a0d3c6cece}">
           <p14:sldIdLst>
             <p14:sldId id="260"/>
-          </p14:sldIdLst>
-        </p14:section>
-        <p14:section name="クロージング" id="{0d5820fc-3538-1e14-453b-6ed3b474f07e}">
-          <p14:sldIdLst>
             <p14:sldId id="261"/>
           </p14:sldIdLst>
         </p14:section>
-        <p14:section name="まとめ" id="{ab77a815-22ed-e6b4-bd2a-884398123636}">
+        <p14:section name="まとめ" id="{51b46ae2-49a8-47cb-3b05-86bc93301334}">
           <p14:sldIdLst>
             <p14:sldId id="262"/>
           </p14:sldIdLst>
@@ -548,7 +544,9 @@
           <a:p>
             <a:r>
               <a:rPr lang="en-US" dirty="0"/>
-              <a:t>これより、ティッシュの提案営業のロールプレイを行います。用途に合わせてお選びいただける2種類のティッシュをご提案します。</a:t>
+              <a:t>「本日はお時間をいただき、ありがとうございます。
+本日は、社内でお使いいただくティッシュについて、用途やご予算に応じてお選びいただける2種類の商品をご提案させていただきたく、お伺いしました。
+まずは、現在の使用状況についてお聞かせいただけますでしょうか。」</a:t>
             </a:r>
             <a:endParaRPr lang="en-US" dirty="0"/>
           </a:p>
@@ -636,13 +634,12 @@
           <a:p>
             <a:r>
               <a:rPr lang="en-US" dirty="0"/>
-              <a:t>「本日は、用途に合わせてお選びいただける2種類のティッシュをご紹介します。
-普段ティッシュを購入される際は、価格と使い心地のどちらを重視されていますか？」
-お客様：「やっぱり価格かな」
-「ありがとうございます。ティッシュは毎日使う消耗品なので、できるだけ費用を抑えたいですよね。
-ちなみに、普段はお食事の際やお掃除など、どのような場面で使われることが多いですか？」
-お客様：「食事のときとか、鼻をかむときかな」
-「ありがとうございます。それでしたら、普段使いと鼻をかむときで、使い分けていただく方法もおすすめです。」</a:t>
+              <a:t>「現在は、どのようなティッシュを、どのような方法で購入されていますか？
+また、毎月どのくらいの量をお使いでしょうか。」
+（使用状況を伺う）
+「企業様にとっては、1箱あたりの価格だけでなく、毎月の使用量を含めた備品購入のコストや、社員の方・ご来客の方の使い心地も大切なポイントになります。
+現在、価格や品質の面で気になっていることはございますか？」
+（課題を伺い、コスト削減と品質重視のどちらを優先されるかを把握する）</a:t>
             </a:r>
             <a:endParaRPr lang="en-US" dirty="0"/>
           </a:p>
@@ -730,11 +727,9 @@
           <a:p>
             <a:r>
               <a:rPr lang="en-US" dirty="0"/>
-              <a:t>「まず、こちらは価格を重視した一般的なティッシュです。
-一番の魅力は、毎日気兼ねなく使えることです。
-例えば、お食事の際に口元を拭いたり、ちょっとした汚れを拭いたり、ご家庭ではさまざまな場面でティッシュを使いますよね。
-そういった使用頻度の高い場面では、価格を抑えられる商品が適していると思います。
-特に、ご家族が多いご家庭や、ティッシュの使用量が多い方にはおすすめです。」</a:t>
+              <a:t>「まず1つ目は、価格を重視したティッシュです。
+価格を抑え、コストパフォーマンスを重視した商品で、社員の方のデスクや給湯室・会議室などの共有スペースといった、日常的に使用する場所に適しています。
+特に、毎月の使用量が多い企業様ほど、備品購入のコスト削減につながります。」</a:t>
             </a:r>
             <a:endParaRPr lang="en-US" dirty="0"/>
           </a:p>
@@ -822,12 +817,10 @@
           <a:p>
             <a:r>
               <a:rPr lang="en-US" dirty="0"/>
-              <a:t>「一方で、こちらは鼻セレブのような、肌触りを重視した高品質なティッシュです。
-一般的なティッシュと比べて価格は高くなりますが、その分、やわらかさや肌への摩擦に配慮した使い心地が魅力です。
-例えば、花粉症や風邪で何度も鼻をかむとき、鼻の周りがヒリヒリしてしまった経験はありませんか？」
-お客様：「あるある！」
-「そうですよね。そんなときには、こちらのようなやわらかいティッシュがおすすめです。
-特に、鼻をかむ回数が増える時期には、毎回の使い心地の違いを感じていただきやすいと思います。」</a:t>
+              <a:t>「2つ目は、鼻セレブのような、柔らかさや肌触りを重視した高品質なティッシュです。
+価格は一般的なティッシュより高くなりますが、その分、使用感に優れています。
+来客スペースや応接室など、快適性を大切にしたい場所でお使いいただくことで、ご来客の方への心配りにもつながります。
+価格だけでなく、品質にも価値を感じていただける企業様におすすめです。」</a:t>
             </a:r>
             <a:endParaRPr lang="en-US" dirty="0"/>
           </a:p>
@@ -915,11 +908,10 @@
           <a:p>
             <a:r>
               <a:rPr lang="en-US" dirty="0"/>
-              <a:t>「ここまで2種類をご紹介しましたが、どちらが良いというよりも、使う場面によって選んでいただくことが大切だと考えています。
-例えば、食卓やリビングには価格重視のティッシュを置いて、寝室や花粉症の時期には高品質なティッシュを使う。
-このように使い分けることで、日々の費用を抑えながら、必要な場面では快適さも大切にできます。
-先ほど価格を重視されるとおっしゃっていましたが、このような使い分けはいかがでしょうか？」
-お客様：「それなら良さそう！」</a:t>
+              <a:t>「どちらか一方に統一するのではなく、オフィス内の用途に合わせて使い分けることをご提案します。
+例えば、社員の方のデスクや共有スペースには価格重視のティッシュを、来客スペースや応接室には高品質なティッシュを置いていただく。
+このように使い分けることで、全体のコストを抑えながら、社員の方やご来客の方の満足度も高めることができます。
+先ほど伺った使用量やご予算を踏まえると、このような配分はいかがでしょうか？」</a:t>
             </a:r>
             <a:endParaRPr lang="en-US" dirty="0"/>
           </a:p>
@@ -1007,10 +999,9 @@
           <a:p>
             <a:r>
               <a:rPr lang="en-US" dirty="0"/>
-              <a:t>「ありがとうございます。
-私からは、普段使いには価格重視のティッシュを、鼻をかむ機会が多いときには高品質なティッシュをおすすめします。
-毎日使うものだからこそ、価格だけでも品質だけでもなく、お客様の生活に合った商品を選んでいただきたいと考えています。
-本日のお話を踏まえて、まずは普段使い用と高品質タイプを一つずつお試しいただくのはいかがでしょうか？」</a:t>
+              <a:t>「いきなり全てを切り替えるのではなく、まずは2種類を少量ずつお試しいただくのはいかがでしょうか。
+実際の使用量や、社員の方・ご来客の方の使い心地をご確認いただいたうえで、貴社に合った配分で本格的に導入いただければと考えております。
+コスト削減を優先されるか、品質を重視されるかに合わせて、配分は柔軟に調整いたします。」</a:t>
             </a:r>
             <a:endParaRPr lang="en-US" dirty="0"/>
           </a:p>
@@ -1098,7 +1089,7 @@
           <a:p>
             <a:r>
               <a:rPr lang="en-US" dirty="0"/>
-              <a:t>「私は営業において、商品の良さを一方的にお伝えするのではなく、お客様が何を大切にされているのかを伺い、その方に合った価値をご提案することを心がけています。」</a:t>
+              <a:t>「私は、商品の特徴を一方的にお伝えするのではなく、ご担当者様のお話を伺ったうえで、コスト削減と品質のどちらを優先されるのかを把握し、貴社にとってメリットのあるご提案をすることを心がけています。本日はありがとうございました。」</a:t>
             </a:r>
             <a:endParaRPr lang="en-US" dirty="0"/>
           </a:p>
@@ -1808,7 +1799,21 @@
                   <a:schemeClr val="bg1"/>
                 </a:solidFill>
               </a:rPr>
-              <a:t>営業ロールプレイ</a:t>
+              <a:t>オフィスのティッシュを、</a:t>
+            </a:r>
+            <a:endParaRPr lang="en-US" sz="3600" dirty="0"/>
+          </a:p>
+          <a:p>
+            <a:pPr algn="l" indent="0" marL="0">
+              <a:buNone/>
+            </a:pPr>
+            <a:r>
+              <a:rPr lang="en-US" sz="3600" b="1" dirty="0">
+                <a:solidFill>
+                  <a:schemeClr val="bg1"/>
+                </a:solidFill>
+              </a:rPr>
+              <a:t>用途に合わせて最適化</a:t>
             </a:r>
             <a:endParaRPr lang="en-US" sz="3600" dirty="0"/>
           </a:p>
@@ -1846,7 +1851,7 @@
                   <a:schemeClr val="accent6"/>
                 </a:solidFill>
               </a:rPr>
-              <a:t>用途に合わせて選ぶ　2種類のティッシュのご提案</a:t>
+              <a:t>用途や予算に応じて選べる　2種類のティッシュのご提案</a:t>
             </a:r>
             <a:endParaRPr lang="en-US" sz="1800" dirty="0"/>
           </a:p>
@@ -1882,7 +1887,7 @@
                   <a:schemeClr val="accent5"/>
                 </a:solidFill>
               </a:rPr>
-              <a:t>テーマ：日用品（ティッシュ）の提案営業｜約5分</a:t>
+              <a:t>総務部・備品管理ご担当者様向け</a:t>
             </a:r>
             <a:endParaRPr lang="en-US" sz="1200" dirty="0"/>
           </a:p>
@@ -2033,7 +2038,7 @@
                   <a:schemeClr val="accent2"/>
                 </a:solidFill>
               </a:rPr>
-              <a:t>① ティッシュ選びのポイント</a:t>
+              <a:t>① 現状の確認</a:t>
             </a:r>
             <a:endParaRPr lang="en-US" sz="1200" dirty="0"/>
           </a:p>
@@ -2071,7 +2076,7 @@
                   <a:schemeClr val="tx2"/>
                 </a:solidFill>
               </a:rPr>
-              <a:t>ティッシュ選びは「価格」と「使う場面」が決め手</a:t>
+              <a:t>ティッシュ選びで見るべき3つの視点</a:t>
             </a:r>
             <a:endParaRPr lang="en-US" sz="2600" dirty="0"/>
           </a:p>
@@ -2079,18 +2084,18 @@
       </p:sp>
       <p:sp>
         <p:nvSpPr>
-          <p:cNvPr id="4" name="Point card"/>
+          <p:cNvPr id="4" name="View card"/>
           <p:cNvSpPr/>
           <p:nvPr/>
         </p:nvSpPr>
         <p:spPr>
           <a:xfrm>
             <a:off x="457200" y="1371600"/>
-            <a:ext cx="5486400" cy="1371600"/>
+            <a:ext cx="5394960" cy="914400"/>
           </a:xfrm>
           <a:prstGeom prst="roundRect">
             <a:avLst>
-              <a:gd name="adj" fmla="val 8000"/>
+              <a:gd name="adj" fmla="val 12000"/>
             </a:avLst>
           </a:prstGeom>
           <a:solidFill>
@@ -2108,27 +2113,27 @@
       </p:sp>
       <p:sp>
         <p:nvSpPr>
-          <p:cNvPr id="5" name="選ぶときの基準 circle"/>
+          <p:cNvPr id="5" name="価格 circle"/>
           <p:cNvSpPr/>
           <p:nvPr/>
         </p:nvSpPr>
         <p:spPr>
           <a:xfrm>
-            <a:off x="731520" y="1645920"/>
-            <a:ext cx="822960" cy="822960"/>
+            <a:off x="685800" y="1508760"/>
+            <a:ext cx="640080" cy="640080"/>
           </a:xfrm>
           <a:prstGeom prst="ellipse">
             <a:avLst/>
           </a:prstGeom>
           <a:solidFill>
-            <a:schemeClr val="accent3"/>
+            <a:schemeClr val="tx2"/>
           </a:solidFill>
           <a:ln/>
         </p:spPr>
       </p:sp>
       <p:pic>
         <p:nvPicPr>
-          <p:cNvPr id="6" name="選ぶときの基準 icon" descr="選ぶときの基準">    </p:cNvPr>
+          <p:cNvPr id="6" name="価格 icon" descr="価格">    </p:cNvPr>
           <p:cNvPicPr>
             <a:picLocks noChangeAspect="1"/>
           </p:cNvPicPr>
@@ -2142,8 +2147,8 @@
         </p:blipFill>
         <p:spPr>
           <a:xfrm>
-            <a:off x="937260" y="1851660"/>
-            <a:ext cx="411480" cy="411480"/>
+            <a:off x="845820" y="1668780"/>
+            <a:ext cx="320040" cy="320040"/>
           </a:xfrm>
           <a:prstGeom prst="rect">
             <a:avLst/>
@@ -2158,8 +2163,8 @@
         </p:nvSpPr>
         <p:spPr>
           <a:xfrm>
-            <a:off x="1828800" y="1600200"/>
-            <a:ext cx="3931920" cy="365760"/>
+            <a:off x="1554480" y="1508760"/>
+            <a:ext cx="4114800" cy="320040"/>
           </a:xfrm>
           <a:prstGeom prst="rect">
             <a:avLst/>
@@ -2180,7 +2185,7 @@
                   <a:schemeClr val="tx2"/>
                 </a:solidFill>
               </a:rPr>
-              <a:t>選ぶときの基準</a:t>
+              <a:t>価格</a:t>
             </a:r>
             <a:endParaRPr lang="en-US" sz="1600" dirty="0"/>
           </a:p>
@@ -2194,8 +2199,8 @@
         </p:nvSpPr>
         <p:spPr>
           <a:xfrm>
-            <a:off x="1828800" y="2011680"/>
-            <a:ext cx="3931920" cy="640080"/>
+            <a:off x="1554480" y="1874520"/>
+            <a:ext cx="4114800" cy="320040"/>
           </a:xfrm>
           <a:prstGeom prst="rect">
             <a:avLst/>
@@ -2216,7 +2221,7 @@
                   <a:schemeClr val="tx1"/>
                 </a:solidFill>
               </a:rPr>
-              <a:t>毎日使う消耗品だからこそ、多くの方が「価格」を重視しています</a:t>
+              <a:t>1箱あたりの単価と、備品購入のコスト</a:t>
             </a:r>
             <a:endParaRPr lang="en-US" sz="1300" dirty="0"/>
           </a:p>
@@ -2224,18 +2229,18 @@
       </p:sp>
       <p:sp>
         <p:nvSpPr>
-          <p:cNvPr id="9" name="Point card"/>
+          <p:cNvPr id="9" name="View card"/>
           <p:cNvSpPr/>
           <p:nvPr/>
         </p:nvSpPr>
         <p:spPr>
           <a:xfrm>
-            <a:off x="457200" y="2971800"/>
-            <a:ext cx="5486400" cy="1371600"/>
+            <a:off x="457200" y="2423160"/>
+            <a:ext cx="5394960" cy="914400"/>
           </a:xfrm>
           <a:prstGeom prst="roundRect">
             <a:avLst>
-              <a:gd name="adj" fmla="val 8000"/>
+              <a:gd name="adj" fmla="val 12000"/>
             </a:avLst>
           </a:prstGeom>
           <a:solidFill>
@@ -2253,27 +2258,27 @@
       </p:sp>
       <p:sp>
         <p:nvSpPr>
-          <p:cNvPr id="10" name="よく使う場面 circle"/>
+          <p:cNvPr id="10" name="使用量 circle"/>
           <p:cNvSpPr/>
           <p:nvPr/>
         </p:nvSpPr>
         <p:spPr>
           <a:xfrm>
-            <a:off x="731520" y="3246120"/>
-            <a:ext cx="822960" cy="822960"/>
+            <a:off x="685800" y="2560320"/>
+            <a:ext cx="640080" cy="640080"/>
           </a:xfrm>
           <a:prstGeom prst="ellipse">
             <a:avLst/>
           </a:prstGeom>
           <a:solidFill>
-            <a:schemeClr val="accent2"/>
+            <a:schemeClr val="accent3"/>
           </a:solidFill>
           <a:ln/>
         </p:spPr>
       </p:sp>
       <p:pic>
         <p:nvPicPr>
-          <p:cNvPr id="11" name="よく使う場面 icon" descr="よく使う場面">    </p:cNvPr>
+          <p:cNvPr id="11" name="使用量 icon" descr="使用量">    </p:cNvPr>
           <p:cNvPicPr>
             <a:picLocks noChangeAspect="1"/>
           </p:cNvPicPr>
@@ -2287,8 +2292,8 @@
         </p:blipFill>
         <p:spPr>
           <a:xfrm>
-            <a:off x="937260" y="3451860"/>
-            <a:ext cx="411480" cy="411480"/>
+            <a:off x="845820" y="2720340"/>
+            <a:ext cx="320040" cy="320040"/>
           </a:xfrm>
           <a:prstGeom prst="rect">
             <a:avLst/>
@@ -2303,8 +2308,8 @@
         </p:nvSpPr>
         <p:spPr>
           <a:xfrm>
-            <a:off x="1828800" y="3200400"/>
-            <a:ext cx="3931920" cy="365760"/>
+            <a:off x="1554480" y="2560320"/>
+            <a:ext cx="4114800" cy="320040"/>
           </a:xfrm>
           <a:prstGeom prst="rect">
             <a:avLst/>
@@ -2325,7 +2330,7 @@
                   <a:schemeClr val="tx2"/>
                 </a:solidFill>
               </a:rPr>
-              <a:t>よく使う場面</a:t>
+              <a:t>使用量</a:t>
             </a:r>
             <a:endParaRPr lang="en-US" sz="1600" dirty="0"/>
           </a:p>
@@ -2339,8 +2344,8 @@
         </p:nvSpPr>
         <p:spPr>
           <a:xfrm>
-            <a:off x="1828800" y="3611880"/>
-            <a:ext cx="3931920" cy="640080"/>
+            <a:off x="1554480" y="2926080"/>
+            <a:ext cx="4114800" cy="320040"/>
           </a:xfrm>
           <a:prstGeom prst="rect">
             <a:avLst/>
@@ -2361,7 +2366,7 @@
                   <a:schemeClr val="tx1"/>
                 </a:solidFill>
               </a:rPr>
-              <a:t>お食事、お掃除、鼻をかむとき。場面によって求める使い心地は異なります</a:t>
+              <a:t>毎月の消費量。社員数が多いほど影響大</a:t>
             </a:r>
             <a:endParaRPr lang="en-US" sz="1300" dirty="0"/>
           </a:p>
@@ -2369,22 +2374,22 @@
       </p:sp>
       <p:sp>
         <p:nvSpPr>
-          <p:cNvPr id="14" name="Insight card"/>
+          <p:cNvPr id="14" name="View card"/>
           <p:cNvSpPr/>
           <p:nvPr/>
         </p:nvSpPr>
         <p:spPr>
           <a:xfrm>
-            <a:off x="6309360" y="1371600"/>
-            <a:ext cx="2377440" cy="2971800"/>
+            <a:off x="457200" y="3474720"/>
+            <a:ext cx="5394960" cy="914400"/>
           </a:xfrm>
           <a:prstGeom prst="roundRect">
             <a:avLst>
-              <a:gd name="adj" fmla="val 4615"/>
+              <a:gd name="adj" fmla="val 12000"/>
             </a:avLst>
           </a:prstGeom>
           <a:solidFill>
-            <a:schemeClr val="tx2"/>
+            <a:schemeClr val="bg2"/>
           </a:solidFill>
           <a:ln/>
           <a:effectLst>
@@ -2396,9 +2401,29 @@
           </a:effectLst>
         </p:spPr>
       </p:sp>
+      <p:sp>
+        <p:nvSpPr>
+          <p:cNvPr id="15" name="品質 circle"/>
+          <p:cNvSpPr/>
+          <p:nvPr/>
+        </p:nvSpPr>
+        <p:spPr>
+          <a:xfrm>
+            <a:off x="685800" y="3611880"/>
+            <a:ext cx="640080" cy="640080"/>
+          </a:xfrm>
+          <a:prstGeom prst="ellipse">
+            <a:avLst/>
+          </a:prstGeom>
+          <a:solidFill>
+            <a:schemeClr val="accent2"/>
+          </a:solidFill>
+          <a:ln/>
+        </p:spPr>
+      </p:sp>
       <p:pic>
         <p:nvPicPr>
-          <p:cNvPr id="15" name="Insight icon" descr="ひらめき">    </p:cNvPr>
+          <p:cNvPr id="16" name="品質 icon" descr="品質">    </p:cNvPr>
           <p:cNvPicPr>
             <a:picLocks noChangeAspect="1"/>
           </p:cNvPicPr>
@@ -2412,50 +2437,14 @@
         </p:blipFill>
         <p:spPr>
           <a:xfrm>
-            <a:off x="6492240" y="1600200"/>
-            <a:ext cx="365760" cy="365760"/>
+            <a:off x="845820" y="3771900"/>
+            <a:ext cx="320040" cy="320040"/>
           </a:xfrm>
           <a:prstGeom prst="rect">
             <a:avLst/>
           </a:prstGeom>
         </p:spPr>
       </p:pic>
-      <p:sp>
-        <p:nvSpPr>
-          <p:cNvPr id="16" name="Text 11"/>
-          <p:cNvSpPr txBox="1"/>
-          <p:nvPr/>
-        </p:nvSpPr>
-        <p:spPr>
-          <a:xfrm>
-            <a:off x="6949440" y="1600200"/>
-            <a:ext cx="1554480" cy="365760"/>
-          </a:xfrm>
-          <a:prstGeom prst="rect">
-            <a:avLst/>
-          </a:prstGeom>
-          <a:noFill/>
-          <a:ln/>
-        </p:spPr>
-        <p:txBody>
-          <a:bodyPr wrap="square" lIns="0" tIns="0" rIns="0" bIns="0" rtlCol="0" anchor="ctr"/>
-          <a:lstStyle/>
-          <a:p>
-            <a:pPr indent="0" marL="0">
-              <a:buNone/>
-            </a:pPr>
-            <a:r>
-              <a:rPr lang="en-US" sz="1400" b="1" dirty="0">
-                <a:solidFill>
-                  <a:schemeClr val="bg1"/>
-                </a:solidFill>
-              </a:rPr>
-              <a:t>ご提案</a:t>
-            </a:r>
-            <a:endParaRPr lang="en-US" sz="1400" dirty="0"/>
-          </a:p>
-        </p:txBody>
-      </p:sp>
       <p:sp>
         <p:nvSpPr>
           <p:cNvPr id="17" name="Text 12"/>
@@ -2464,8 +2453,8 @@
         </p:nvSpPr>
         <p:spPr>
           <a:xfrm>
-            <a:off x="6492240" y="2148840"/>
-            <a:ext cx="2011680" cy="822960"/>
+            <a:off x="1554480" y="3611880"/>
+            <a:ext cx="4114800" cy="320040"/>
           </a:xfrm>
           <a:prstGeom prst="rect">
             <a:avLst/>
@@ -2481,28 +2470,14 @@
               <a:buNone/>
             </a:pPr>
             <a:r>
-              <a:rPr lang="en-US" sz="1500" b="1" dirty="0">
-                <a:solidFill>
-                  <a:schemeClr val="accent4"/>
-                </a:solidFill>
-              </a:rPr>
-              <a:t>1種類に絞らず、</a:t>
-            </a:r>
-            <a:endParaRPr lang="en-US" sz="1500" dirty="0"/>
-          </a:p>
-          <a:p>
-            <a:pPr indent="0" marL="0">
-              <a:buNone/>
-            </a:pPr>
-            <a:r>
-              <a:rPr lang="en-US" sz="1500" b="1" dirty="0">
-                <a:solidFill>
-                  <a:schemeClr val="accent4"/>
-                </a:solidFill>
-              </a:rPr>
-              <a:t>場面ごとに使い分ける</a:t>
-            </a:r>
-            <a:endParaRPr lang="en-US" sz="1500" dirty="0"/>
+              <a:rPr lang="en-US" sz="1600" b="1" dirty="0">
+                <a:solidFill>
+                  <a:schemeClr val="tx2"/>
+                </a:solidFill>
+              </a:rPr>
+              <a:t>品質</a:t>
+            </a:r>
+            <a:endParaRPr lang="en-US" sz="1600" dirty="0"/>
           </a:p>
         </p:txBody>
       </p:sp>
@@ -2514,8 +2489,8 @@
         </p:nvSpPr>
         <p:spPr>
           <a:xfrm>
-            <a:off x="6492240" y="3063240"/>
-            <a:ext cx="2011680" cy="1188720"/>
+            <a:off x="1554480" y="3977640"/>
+            <a:ext cx="4114800" cy="320040"/>
           </a:xfrm>
           <a:prstGeom prst="rect">
             <a:avLst/>
@@ -2528,69 +2503,234 @@
           <a:lstStyle/>
           <a:p>
             <a:pPr indent="0" marL="0">
+              <a:buNone/>
+            </a:pPr>
+            <a:r>
+              <a:rPr lang="en-US" sz="1300" dirty="0">
+                <a:solidFill>
+                  <a:schemeClr val="tx1"/>
+                </a:solidFill>
+              </a:rPr>
+              <a:t>社員や来客にとっての使い心地</a:t>
+            </a:r>
+            <a:endParaRPr lang="en-US" sz="1300" dirty="0"/>
+          </a:p>
+        </p:txBody>
+      </p:sp>
+      <p:sp>
+        <p:nvSpPr>
+          <p:cNvPr id="19" name="Hearing card"/>
+          <p:cNvSpPr/>
+          <p:nvPr/>
+        </p:nvSpPr>
+        <p:spPr>
+          <a:xfrm>
+            <a:off x="6217920" y="1371600"/>
+            <a:ext cx="2468880" cy="3017520"/>
+          </a:xfrm>
+          <a:prstGeom prst="roundRect">
+            <a:avLst>
+              <a:gd name="adj" fmla="val 4444"/>
+            </a:avLst>
+          </a:prstGeom>
+          <a:solidFill>
+            <a:schemeClr val="tx2"/>
+          </a:solidFill>
+          <a:ln/>
+          <a:effectLst>
+            <a:outerShdw sx="100000" sy="100000" kx="0" ky="0" algn="bl" rotWithShape="0" blurRad="76200" dist="25400" dir="5400000">
+              <a:srgbClr val="000000">
+                <a:alpha val="12000"/>
+              </a:srgbClr>
+            </a:outerShdw>
+          </a:effectLst>
+        </p:spPr>
+      </p:sp>
+      <p:pic>
+        <p:nvPicPr>
+          <p:cNvPr id="20" name="Hearing icon" descr="ヒアリング">    </p:cNvPr>
+          <p:cNvPicPr>
+            <a:picLocks noChangeAspect="1"/>
+          </p:cNvPicPr>
+          <p:nvPr/>
+        </p:nvPicPr>
+        <p:blipFill>
+          <a:blip r:embed="rId4"/>
+          <a:stretch>
+            <a:fillRect/>
+          </a:stretch>
+        </p:blipFill>
+        <p:spPr>
+          <a:xfrm>
+            <a:off x="6400800" y="1554480"/>
+            <a:ext cx="365760" cy="365760"/>
+          </a:xfrm>
+          <a:prstGeom prst="rect">
+            <a:avLst/>
+          </a:prstGeom>
+        </p:spPr>
+      </p:pic>
+      <p:sp>
+        <p:nvSpPr>
+          <p:cNvPr id="21" name="Text 15"/>
+          <p:cNvSpPr txBox="1"/>
+          <p:nvPr/>
+        </p:nvSpPr>
+        <p:spPr>
+          <a:xfrm>
+            <a:off x="6858000" y="1554480"/>
+            <a:ext cx="1737360" cy="365760"/>
+          </a:xfrm>
+          <a:prstGeom prst="rect">
+            <a:avLst/>
+          </a:prstGeom>
+          <a:noFill/>
+          <a:ln/>
+        </p:spPr>
+        <p:txBody>
+          <a:bodyPr wrap="square" lIns="0" tIns="0" rIns="0" bIns="0" rtlCol="0" anchor="ctr"/>
+          <a:lstStyle/>
+          <a:p>
+            <a:pPr indent="0" marL="0">
+              <a:buNone/>
+            </a:pPr>
+            <a:r>
+              <a:rPr lang="en-US" sz="1300" b="1" dirty="0">
+                <a:solidFill>
+                  <a:schemeClr val="bg1"/>
+                </a:solidFill>
+              </a:rPr>
+              <a:t>お伺いしたいこと</a:t>
+            </a:r>
+            <a:endParaRPr lang="en-US" sz="1300" dirty="0"/>
+          </a:p>
+        </p:txBody>
+      </p:sp>
+      <p:sp>
+        <p:nvSpPr>
+          <p:cNvPr id="22" name="Text 16"/>
+          <p:cNvSpPr txBox="1"/>
+          <p:nvPr/>
+        </p:nvSpPr>
+        <p:spPr>
+          <a:xfrm>
+            <a:off x="6400800" y="2148840"/>
+            <a:ext cx="2103120" cy="1371600"/>
+          </a:xfrm>
+          <a:prstGeom prst="rect">
+            <a:avLst/>
+          </a:prstGeom>
+          <a:noFill/>
+          <a:ln/>
+        </p:spPr>
+        <p:txBody>
+          <a:bodyPr wrap="square" lIns="0" tIns="0" rIns="0" bIns="0" rtlCol="0" anchor="t"/>
+          <a:lstStyle/>
+          <a:p>
+            <a:pPr marL="342900" indent="-342900">
               <a:spcAft>
-                <a:spcPts val="200"/>
+                <a:spcPts val="600"/>
               </a:spcAft>
-              <a:buNone/>
-            </a:pPr>
-            <a:r>
-              <a:rPr lang="en-US" sz="1100" dirty="0">
-                <a:solidFill>
-                  <a:schemeClr val="accent6"/>
-                </a:solidFill>
-              </a:rPr>
-              <a:t>普段使い</a:t>
+              <a:buSzPct val="100000"/>
+              <a:buChar char="•"/>
+            </a:pPr>
+            <a:r>
+              <a:rPr lang="en-US" sz="1300" dirty="0">
+                <a:solidFill>
+                  <a:schemeClr val="bg1"/>
+                </a:solidFill>
+              </a:rPr>
+              <a:t>現在お使いの商品</a:t>
             </a:r>
             <a:endParaRPr lang="en-US" sz="1300" dirty="0"/>
           </a:p>
           <a:p>
+            <a:pPr marL="342900" indent="-342900">
+              <a:spcAft>
+                <a:spcPts val="600"/>
+              </a:spcAft>
+              <a:buSzPct val="100000"/>
+              <a:buChar char="•"/>
+            </a:pPr>
+            <a:r>
+              <a:rPr lang="en-US" sz="1300" dirty="0">
+                <a:solidFill>
+                  <a:schemeClr val="bg1"/>
+                </a:solidFill>
+              </a:rPr>
+              <a:t>購入方法・購入頻度</a:t>
+            </a:r>
+            <a:endParaRPr lang="en-US" sz="1300" dirty="0"/>
+          </a:p>
+          <a:p>
+            <a:pPr marL="342900" indent="-342900">
+              <a:spcAft>
+                <a:spcPts val="600"/>
+              </a:spcAft>
+              <a:buSzPct val="100000"/>
+              <a:buChar char="•"/>
+            </a:pPr>
+            <a:r>
+              <a:rPr lang="en-US" sz="1300" dirty="0">
+                <a:solidFill>
+                  <a:schemeClr val="bg1"/>
+                </a:solidFill>
+              </a:rPr>
+              <a:t>毎月の使用量</a:t>
+            </a:r>
+            <a:endParaRPr lang="en-US" sz="1300" dirty="0"/>
+          </a:p>
+          <a:p>
+            <a:pPr marL="342900" indent="-342900">
+              <a:spcAft>
+                <a:spcPts val="600"/>
+              </a:spcAft>
+              <a:buSzPct val="100000"/>
+              <a:buChar char="•"/>
+            </a:pPr>
+            <a:r>
+              <a:rPr lang="en-US" sz="1300" dirty="0">
+                <a:solidFill>
+                  <a:schemeClr val="bg1"/>
+                </a:solidFill>
+              </a:rPr>
+              <a:t>価格・品質の課題</a:t>
+            </a:r>
+            <a:endParaRPr lang="en-US" sz="1300" dirty="0"/>
+          </a:p>
+        </p:txBody>
+      </p:sp>
+      <p:sp>
+        <p:nvSpPr>
+          <p:cNvPr id="23" name="Text 17"/>
+          <p:cNvSpPr txBox="1"/>
+          <p:nvPr/>
+        </p:nvSpPr>
+        <p:spPr>
+          <a:xfrm>
+            <a:off x="6400800" y="3703320"/>
+            <a:ext cx="2103120" cy="457200"/>
+          </a:xfrm>
+          <a:prstGeom prst="rect">
+            <a:avLst/>
+          </a:prstGeom>
+          <a:noFill/>
+          <a:ln/>
+        </p:spPr>
+        <p:txBody>
+          <a:bodyPr wrap="square" lIns="0" tIns="0" rIns="0" bIns="0" rtlCol="0" anchor="t"/>
+          <a:lstStyle/>
+          <a:p>
             <a:pPr indent="0" marL="0">
-              <a:spcAft>
-                <a:spcPts val="200"/>
-              </a:spcAft>
               <a:buNone/>
             </a:pPr>
             <a:r>
               <a:rPr lang="en-US" sz="1300" b="1" dirty="0">
                 <a:solidFill>
-                  <a:schemeClr val="bg1"/>
-                </a:solidFill>
-              </a:rPr>
-              <a:t>→ 価格重視タイプ</a:t>
-            </a:r>
-            <a:endParaRPr lang="en-US" sz="1300" dirty="0"/>
-          </a:p>
-          <a:p>
-            <a:pPr indent="0" marL="0">
-              <a:spcAft>
-                <a:spcPts val="200"/>
-              </a:spcAft>
-              <a:buNone/>
-            </a:pPr>
-            <a:r>
-              <a:rPr lang="en-US" sz="1100" dirty="0">
-                <a:solidFill>
-                  <a:schemeClr val="accent6"/>
-                </a:solidFill>
-              </a:rPr>
-              <a:t>鼻をかむとき</a:t>
-            </a:r>
-            <a:endParaRPr lang="en-US" sz="1300" dirty="0"/>
-          </a:p>
-          <a:p>
-            <a:pPr indent="0" marL="0">
-              <a:spcAft>
-                <a:spcPts val="200"/>
-              </a:spcAft>
-              <a:buNone/>
-            </a:pPr>
-            <a:r>
-              <a:rPr lang="en-US" sz="1300" b="1" dirty="0">
-                <a:solidFill>
-                  <a:schemeClr val="bg1"/>
-                </a:solidFill>
-              </a:rPr>
-              <a:t>→ 高品質タイプ</a:t>
+                  <a:schemeClr val="accent4"/>
+                </a:solidFill>
+              </a:rPr>
+              <a:t>コスト削減か、品質重視か</a:t>
             </a:r>
             <a:endParaRPr lang="en-US" sz="1300" dirty="0"/>
           </a:p>
@@ -2736,7 +2876,7 @@
                   <a:schemeClr val="tx2"/>
                 </a:solidFill>
               </a:rPr>
-              <a:t>毎日、気兼ねなく使える</a:t>
+              <a:t>コストを抑えて、毎日たっぷり使える</a:t>
             </a:r>
             <a:endParaRPr lang="en-US" sz="2600" dirty="0"/>
           </a:p>
@@ -2881,7 +3021,7 @@
                   <a:schemeClr val="bg1"/>
                 </a:solidFill>
               </a:rPr>
-              <a:t>一般的なティッシュ</a:t>
+              <a:t>コストパフォーマンス重視</a:t>
             </a:r>
             <a:endParaRPr lang="en-US" sz="1200" dirty="0"/>
           </a:p>
@@ -2895,7 +3035,7 @@
                   <a:schemeClr val="bg1"/>
                 </a:solidFill>
               </a:rPr>
-              <a:t>使用頻度の高い場面に</a:t>
+              <a:t>日常使いの定番に</a:t>
             </a:r>
             <a:endParaRPr lang="en-US" sz="1200" dirty="0"/>
           </a:p>
@@ -2903,7 +3043,7 @@
       </p:sp>
       <p:sp>
         <p:nvSpPr>
-          <p:cNvPr id="9" name="お食事のときに circle"/>
+          <p:cNvPr id="9" name="デスク・執務スペースに circle"/>
           <p:cNvSpPr/>
           <p:nvPr/>
         </p:nvSpPr>
@@ -2923,7 +3063,7 @@
       </p:sp>
       <p:pic>
         <p:nvPicPr>
-          <p:cNvPr id="10" name="お食事のときに icon" descr="お食事のときに">    </p:cNvPr>
+          <p:cNvPr id="10" name="デスク・執務スペースに icon" descr="デスク・執務スペースに">    </p:cNvPr>
           <p:cNvPicPr>
             <a:picLocks noChangeAspect="1"/>
           </p:cNvPicPr>
@@ -2975,7 +3115,7 @@
                   <a:schemeClr val="tx2"/>
                 </a:solidFill>
               </a:rPr>
-              <a:t>お食事のときに</a:t>
+              <a:t>デスク・執務スペースに</a:t>
             </a:r>
             <a:endParaRPr lang="en-US" sz="1500" dirty="0"/>
           </a:p>
@@ -3011,7 +3151,7 @@
                   <a:schemeClr val="tx1"/>
                 </a:solidFill>
               </a:rPr>
-              <a:t>口元を拭くなど、毎日何度も使う場面に</a:t>
+              <a:t>社員の皆様が毎日使う場所に、気兼ねなく置ける</a:t>
             </a:r>
             <a:endParaRPr lang="en-US" sz="1200" dirty="0"/>
           </a:p>
@@ -3019,7 +3159,7 @@
       </p:sp>
       <p:sp>
         <p:nvSpPr>
-          <p:cNvPr id="13" name="ちょっとした汚れに circle"/>
+          <p:cNvPr id="13" name="共有スペースに circle"/>
           <p:cNvSpPr/>
           <p:nvPr/>
         </p:nvSpPr>
@@ -3039,7 +3179,7 @@
       </p:sp>
       <p:pic>
         <p:nvPicPr>
-          <p:cNvPr id="14" name="ちょっとした汚れに icon" descr="ちょっとした汚れに">    </p:cNvPr>
+          <p:cNvPr id="14" name="共有スペースに icon" descr="共有スペースに">    </p:cNvPr>
           <p:cNvPicPr>
             <a:picLocks noChangeAspect="1"/>
           </p:cNvPicPr>
@@ -3091,7 +3231,7 @@
                   <a:schemeClr val="tx2"/>
                 </a:solidFill>
               </a:rPr>
-              <a:t>ちょっとした汚れに</a:t>
+              <a:t>共有スペースに</a:t>
             </a:r>
             <a:endParaRPr lang="en-US" sz="1500" dirty="0"/>
           </a:p>
@@ -3127,7 +3267,7 @@
                   <a:schemeClr val="tx1"/>
                 </a:solidFill>
               </a:rPr>
-              <a:t>テーブルや手元をさっと拭きたいときに</a:t>
+              <a:t>給湯室や会議室など、使用頻度の高い場所に</a:t>
             </a:r>
             <a:endParaRPr lang="en-US" sz="1200" dirty="0"/>
           </a:p>
@@ -3135,7 +3275,7 @@
       </p:sp>
       <p:sp>
         <p:nvSpPr>
-          <p:cNvPr id="17" name="ご家族が多いご家庭に circle"/>
+          <p:cNvPr id="17" name="使用量の多い企業様に circle"/>
           <p:cNvSpPr/>
           <p:nvPr/>
         </p:nvSpPr>
@@ -3155,7 +3295,7 @@
       </p:sp>
       <p:pic>
         <p:nvPicPr>
-          <p:cNvPr id="18" name="ご家族が多いご家庭に icon" descr="ご家族が多いご家庭に">    </p:cNvPr>
+          <p:cNvPr id="18" name="使用量の多い企業様に icon" descr="使用量の多い企業様に">    </p:cNvPr>
           <p:cNvPicPr>
             <a:picLocks noChangeAspect="1"/>
           </p:cNvPicPr>
@@ -3207,7 +3347,7 @@
                   <a:schemeClr val="tx2"/>
                 </a:solidFill>
               </a:rPr>
-              <a:t>ご家族が多いご家庭に</a:t>
+              <a:t>使用量の多い企業様に</a:t>
             </a:r>
             <a:endParaRPr lang="en-US" sz="1500" dirty="0"/>
           </a:p>
@@ -3243,7 +3383,7 @@
                   <a:schemeClr val="tx1"/>
                 </a:solidFill>
               </a:rPr>
-              <a:t>使用量が多くても、費用を抑えられます</a:t>
+              <a:t>消費量が多いほど、コスト削減の効果が大きくなる</a:t>
             </a:r>
             <a:endParaRPr lang="en-US" sz="1200" dirty="0"/>
           </a:p>
@@ -3389,7 +3529,7 @@
                   <a:schemeClr val="tx2"/>
                 </a:solidFill>
               </a:rPr>
-              <a:t>鼻をかむたびに、やさしい使い心地</a:t>
+              <a:t>来客や快適性を大切にしたい場所に</a:t>
             </a:r>
             <a:endParaRPr lang="en-US" sz="2600" dirty="0"/>
           </a:p>
@@ -3548,7 +3688,7 @@
                   <a:schemeClr val="bg1"/>
                 </a:solidFill>
               </a:rPr>
-              <a:t>肌触り重視のティッシュ</a:t>
+              <a:t>使用感重視のティッシュ</a:t>
             </a:r>
             <a:endParaRPr lang="en-US" sz="1200" dirty="0"/>
           </a:p>
@@ -3556,7 +3696,7 @@
       </p:sp>
       <p:sp>
         <p:nvSpPr>
-          <p:cNvPr id="9" name="やわらかさ circle"/>
+          <p:cNvPr id="9" name="やわらかさ・肌触り circle"/>
           <p:cNvSpPr/>
           <p:nvPr/>
         </p:nvSpPr>
@@ -3576,7 +3716,7 @@
       </p:sp>
       <p:pic>
         <p:nvPicPr>
-          <p:cNvPr id="10" name="やわらかさ icon" descr="やわらかさ">    </p:cNvPr>
+          <p:cNvPr id="10" name="やわらかさ・肌触り icon" descr="やわらかさ・肌触り">    </p:cNvPr>
           <p:cNvPicPr>
             <a:picLocks noChangeAspect="1"/>
           </p:cNvPicPr>
@@ -3628,7 +3768,7 @@
                   <a:schemeClr val="tx2"/>
                 </a:solidFill>
               </a:rPr>
-              <a:t>やわらかさ</a:t>
+              <a:t>やわらかさ・肌触り</a:t>
             </a:r>
             <a:endParaRPr lang="en-US" sz="1500" dirty="0"/>
           </a:p>
@@ -3664,7 +3804,7 @@
                   <a:schemeClr val="tx1"/>
                 </a:solidFill>
               </a:rPr>
-              <a:t>一般的なティッシュよりも、しっとりやわらか</a:t>
+              <a:t>一般的なティッシュよりも、しっとりやわらかい使用感</a:t>
             </a:r>
             <a:endParaRPr lang="en-US" sz="1200" dirty="0"/>
           </a:p>
@@ -3672,7 +3812,7 @@
       </p:sp>
       <p:sp>
         <p:nvSpPr>
-          <p:cNvPr id="13" name="肌への摩擦に配慮 circle"/>
+          <p:cNvPr id="13" name="来客スペース・応接室に circle"/>
           <p:cNvSpPr/>
           <p:nvPr/>
         </p:nvSpPr>
@@ -3692,7 +3832,7 @@
       </p:sp>
       <p:pic>
         <p:nvPicPr>
-          <p:cNvPr id="14" name="肌への摩擦に配慮 icon" descr="肌への摩擦に配慮">    </p:cNvPr>
+          <p:cNvPr id="14" name="来客スペース・応接室に icon" descr="来客スペース・応接室に">    </p:cNvPr>
           <p:cNvPicPr>
             <a:picLocks noChangeAspect="1"/>
           </p:cNvPicPr>
@@ -3744,7 +3884,7 @@
                   <a:schemeClr val="tx2"/>
                 </a:solidFill>
               </a:rPr>
-              <a:t>肌への摩擦に配慮</a:t>
+              <a:t>来客スペース・応接室に</a:t>
             </a:r>
             <a:endParaRPr lang="en-US" sz="1500" dirty="0"/>
           </a:p>
@@ -3780,7 +3920,7 @@
                   <a:schemeClr val="tx1"/>
                 </a:solidFill>
               </a:rPr>
-              <a:t>何度使っても、鼻の周りにやさしい</a:t>
+              <a:t>お客様をお迎えする場所で、細やかな心配りを</a:t>
             </a:r>
             <a:endParaRPr lang="en-US" sz="1200" dirty="0"/>
           </a:p>
@@ -3788,7 +3928,7 @@
       </p:sp>
       <p:sp>
         <p:nvSpPr>
-          <p:cNvPr id="17" name="花粉症・風邪の時期に circle"/>
+          <p:cNvPr id="17" name="品質を重視する企業様に circle"/>
           <p:cNvSpPr/>
           <p:nvPr/>
         </p:nvSpPr>
@@ -3808,7 +3948,7 @@
       </p:sp>
       <p:pic>
         <p:nvPicPr>
-          <p:cNvPr id="18" name="花粉症・風邪の時期に icon" descr="花粉症・風邪の時期に">    </p:cNvPr>
+          <p:cNvPr id="18" name="品質を重視する企業様に icon" descr="品質を重視する企業様に">    </p:cNvPr>
           <p:cNvPicPr>
             <a:picLocks noChangeAspect="1"/>
           </p:cNvPicPr>
@@ -3860,7 +4000,7 @@
                   <a:schemeClr val="tx2"/>
                 </a:solidFill>
               </a:rPr>
-              <a:t>花粉症・風邪の時期に</a:t>
+              <a:t>品質を重視する企業様に</a:t>
             </a:r>
             <a:endParaRPr lang="en-US" sz="1500" dirty="0"/>
           </a:p>
@@ -3896,7 +4036,7 @@
                   <a:schemeClr val="tx1"/>
                 </a:solidFill>
               </a:rPr>
-              <a:t>鼻をかむ回数が増えるほど、違いを実感</a:t>
+              <a:t>価格だけでなく、使い心地にも価値を感じる企業様に</a:t>
             </a:r>
             <a:endParaRPr lang="en-US" sz="1200" dirty="0"/>
           </a:p>
@@ -4042,7 +4182,7 @@
                   <a:schemeClr val="tx2"/>
                 </a:solidFill>
               </a:rPr>
-              <a:t>どちらが良いかではなく、場面で使い分ける</a:t>
+              <a:t>オフィス内の用途に合わせて使い分ける</a:t>
             </a:r>
             <a:endParaRPr lang="en-US" sz="2600" dirty="0"/>
           </a:p>
@@ -4079,7 +4219,7 @@
       </p:sp>
       <p:sp>
         <p:nvSpPr>
-          <p:cNvPr id="5" name="食卓・リビング circle"/>
+          <p:cNvPr id="5" name="デスク・共有スペース circle"/>
           <p:cNvSpPr/>
           <p:nvPr/>
         </p:nvSpPr>
@@ -4099,7 +4239,7 @@
       </p:sp>
       <p:pic>
         <p:nvPicPr>
-          <p:cNvPr id="6" name="食卓・リビング icon" descr="食卓・リビング">    </p:cNvPr>
+          <p:cNvPr id="6" name="デスク・共有スペース icon" descr="デスク・共有スペース">    </p:cNvPr>
           <p:cNvPicPr>
             <a:picLocks noChangeAspect="1"/>
           </p:cNvPicPr>
@@ -4146,14 +4286,14 @@
               <a:buNone/>
             </a:pPr>
             <a:r>
-              <a:rPr lang="en-US" sz="1800" b="1" dirty="0">
+              <a:rPr lang="en-US" sz="1700" b="1" dirty="0">
                 <a:solidFill>
                   <a:schemeClr val="tx2"/>
                 </a:solidFill>
               </a:rPr>
-              <a:t>食卓・リビング</a:t>
-            </a:r>
-            <a:endParaRPr lang="en-US" sz="1800" dirty="0"/>
+              <a:t>デスク・共有スペース</a:t>
+            </a:r>
+            <a:endParaRPr lang="en-US" sz="1700" dirty="0"/>
           </a:p>
         </p:txBody>
       </p:sp>
@@ -4224,7 +4364,7 @@
         <p:spPr>
           <a:xfrm>
             <a:off x="731520" y="2743200"/>
-            <a:ext cx="3474720" cy="548640"/>
+            <a:ext cx="3474720" cy="365760"/>
           </a:xfrm>
           <a:prstGeom prst="rect">
             <a:avLst/>
@@ -4245,7 +4385,7 @@
                   <a:schemeClr val="tx1"/>
                 </a:solidFill>
               </a:rPr>
-              <a:t>毎日たくさん使う場所は、費用を抑えて</a:t>
+              <a:t>使用量の多い場所は、コストを抑えて</a:t>
             </a:r>
             <a:endParaRPr lang="en-US" sz="1300" dirty="0"/>
           </a:p>
@@ -4282,7 +4422,7 @@
       </p:sp>
       <p:sp>
         <p:nvSpPr>
-          <p:cNvPr id="12" name="寝室・花粉症の時期 circle"/>
+          <p:cNvPr id="12" name="来客スペース・応接室 circle"/>
           <p:cNvSpPr/>
           <p:nvPr/>
         </p:nvSpPr>
@@ -4302,7 +4442,7 @@
       </p:sp>
       <p:pic>
         <p:nvPicPr>
-          <p:cNvPr id="13" name="寝室・花粉症の時期 icon" descr="寝室・花粉症の時期">    </p:cNvPr>
+          <p:cNvPr id="13" name="来客スペース・応接室 icon" descr="来客スペース・応接室">    </p:cNvPr>
           <p:cNvPicPr>
             <a:picLocks noChangeAspect="1"/>
           </p:cNvPicPr>
@@ -4349,14 +4489,14 @@
               <a:buNone/>
             </a:pPr>
             <a:r>
-              <a:rPr lang="en-US" sz="1800" b="1" dirty="0">
+              <a:rPr lang="en-US" sz="1700" b="1" dirty="0">
                 <a:solidFill>
                   <a:schemeClr val="tx2"/>
                 </a:solidFill>
               </a:rPr>
-              <a:t>寝室・花粉症の時期</a:t>
-            </a:r>
-            <a:endParaRPr lang="en-US" sz="1800" dirty="0"/>
+              <a:t>来客スペース・応接室</a:t>
+            </a:r>
+            <a:endParaRPr lang="en-US" sz="1700" dirty="0"/>
           </a:p>
         </p:txBody>
       </p:sp>
@@ -4427,7 +4567,7 @@
         <p:spPr>
           <a:xfrm>
             <a:off x="4937760" y="2743200"/>
-            <a:ext cx="3474720" cy="548640"/>
+            <a:ext cx="3474720" cy="365760"/>
           </a:xfrm>
           <a:prstGeom prst="rect">
             <a:avLst/>
@@ -4448,7 +4588,7 @@
                   <a:schemeClr val="tx1"/>
                 </a:solidFill>
               </a:rPr>
-              <a:t>鼻をかむ場面は、肌へのやさしさを</a:t>
+              <a:t>お客様をお迎えする場所は、品質を重視して</a:t>
             </a:r>
             <a:endParaRPr lang="en-US" sz="1300" dirty="0"/>
           </a:p>
@@ -4513,7 +4653,7 @@
                   <a:schemeClr val="bg1"/>
                 </a:solidFill>
               </a:rPr>
-              <a:t>日々の費用を抑えながら、必要な場面では快適さも大切にできる</a:t>
+              <a:t>全体のコストを抑えながら、社員と来客の満足度も高める</a:t>
             </a:r>
             <a:endParaRPr lang="en-US" sz="1600" dirty="0"/>
           </a:p>
@@ -4621,7 +4761,7 @@
                   <a:schemeClr val="accent2"/>
                 </a:solidFill>
               </a:rPr>
-              <a:t>⑤ ご提案</a:t>
+              <a:t>⑤ 導入のご提案</a:t>
             </a:r>
             <a:endParaRPr lang="en-US" sz="1200" dirty="0"/>
           </a:p>
@@ -4659,7 +4799,7 @@
                   <a:schemeClr val="tx2"/>
                 </a:solidFill>
               </a:rPr>
-              <a:t>まずは、1つずつお試しください</a:t>
+              <a:t>まずは、お試し購入から</a:t>
             </a:r>
             <a:endParaRPr lang="en-US" sz="2600" dirty="0"/>
           </a:p>
@@ -4667,22 +4807,22 @@
       </p:sp>
       <p:sp>
         <p:nvSpPr>
-          <p:cNvPr id="4" name="Trial card"/>
+          <p:cNvPr id="4" name="Step card"/>
           <p:cNvSpPr/>
           <p:nvPr/>
         </p:nvSpPr>
         <p:spPr>
           <a:xfrm>
-            <a:off x="822960" y="1371600"/>
-            <a:ext cx="3200400" cy="1828800"/>
+            <a:off x="457200" y="1371600"/>
+            <a:ext cx="2468880" cy="2286000"/>
           </a:xfrm>
           <a:prstGeom prst="roundRect">
             <a:avLst>
-              <a:gd name="adj" fmla="val 6000"/>
+              <a:gd name="adj" fmla="val 4800"/>
             </a:avLst>
           </a:prstGeom>
           <a:solidFill>
-            <a:schemeClr val="accent3"/>
+            <a:schemeClr val="bg2"/>
           </a:solidFill>
           <a:ln/>
           <a:effectLst>
@@ -4694,9 +4834,29 @@
           </a:effectLst>
         </p:spPr>
       </p:sp>
+      <p:sp>
+        <p:nvSpPr>
+          <p:cNvPr id="5" name="お試し購入 circle"/>
+          <p:cNvSpPr/>
+          <p:nvPr/>
+        </p:nvSpPr>
+        <p:spPr>
+          <a:xfrm>
+            <a:off x="1325880" y="1600200"/>
+            <a:ext cx="731520" cy="731520"/>
+          </a:xfrm>
+          <a:prstGeom prst="ellipse">
+            <a:avLst/>
+          </a:prstGeom>
+          <a:solidFill>
+            <a:schemeClr val="accent3"/>
+          </a:solidFill>
+          <a:ln/>
+        </p:spPr>
+      </p:sp>
       <p:pic>
         <p:nvPicPr>
-          <p:cNvPr id="5" name="Trial icon" descr="価格重視タイプ">    </p:cNvPr>
+          <p:cNvPr id="6" name="お試し購入 icon" descr="お試し購入">    </p:cNvPr>
           <p:cNvPicPr>
             <a:picLocks noChangeAspect="1"/>
           </p:cNvPicPr>
@@ -4710,50 +4870,14 @@
         </p:blipFill>
         <p:spPr>
           <a:xfrm>
-            <a:off x="1097280" y="1600200"/>
-            <a:ext cx="548640" cy="548640"/>
+            <a:off x="1508760" y="1783080"/>
+            <a:ext cx="365760" cy="365760"/>
           </a:xfrm>
           <a:prstGeom prst="rect">
             <a:avLst/>
           </a:prstGeom>
         </p:spPr>
       </p:pic>
-      <p:sp>
-        <p:nvSpPr>
-          <p:cNvPr id="6" name="Text 3"/>
-          <p:cNvSpPr txBox="1"/>
-          <p:nvPr/>
-        </p:nvSpPr>
-        <p:spPr>
-          <a:xfrm>
-            <a:off x="1097280" y="2286000"/>
-            <a:ext cx="2743200" cy="320040"/>
-          </a:xfrm>
-          <a:prstGeom prst="rect">
-            <a:avLst/>
-          </a:prstGeom>
-          <a:noFill/>
-          <a:ln/>
-        </p:spPr>
-        <p:txBody>
-          <a:bodyPr wrap="square" lIns="0" tIns="0" rIns="0" bIns="0" rtlCol="0" anchor="t"/>
-          <a:lstStyle/>
-          <a:p>
-            <a:pPr indent="0" marL="0">
-              <a:buNone/>
-            </a:pPr>
-            <a:r>
-              <a:rPr lang="en-US" sz="1300" dirty="0">
-                <a:solidFill>
-                  <a:schemeClr val="bg1"/>
-                </a:solidFill>
-              </a:rPr>
-              <a:t>普段使い用</a:t>
-            </a:r>
-            <a:endParaRPr lang="en-US" sz="1300" dirty="0"/>
-          </a:p>
-        </p:txBody>
-      </p:sp>
       <p:sp>
         <p:nvSpPr>
           <p:cNvPr id="7" name="Text 4"/>
@@ -4762,8 +4886,8 @@
         </p:nvSpPr>
         <p:spPr>
           <a:xfrm>
-            <a:off x="1097280" y="2606040"/>
-            <a:ext cx="2743200" cy="411480"/>
+            <a:off x="640080" y="2468880"/>
+            <a:ext cx="2103120" cy="274320"/>
           </a:xfrm>
           <a:prstGeom prst="rect">
             <a:avLst/>
@@ -4775,39 +4899,149 @@
           <a:bodyPr wrap="square" lIns="0" tIns="0" rIns="0" bIns="0" rtlCol="0" anchor="t"/>
           <a:lstStyle/>
           <a:p>
-            <a:pPr indent="0" marL="0">
-              <a:buNone/>
-            </a:pPr>
-            <a:r>
-              <a:rPr lang="en-US" sz="2000" b="1" dirty="0">
-                <a:solidFill>
-                  <a:schemeClr val="bg1"/>
-                </a:solidFill>
-              </a:rPr>
-              <a:t>価格重視タイプ</a:t>
-            </a:r>
-            <a:endParaRPr lang="en-US" sz="2000" dirty="0"/>
-          </a:p>
-        </p:txBody>
-      </p:sp>
-      <p:sp>
-        <p:nvSpPr>
-          <p:cNvPr id="8" name="Trial card"/>
+            <a:pPr algn="ctr" indent="0" marL="0">
+              <a:buNone/>
+            </a:pPr>
+            <a:r>
+              <a:rPr lang="en-US" sz="1100" b="1" dirty="0">
+                <a:solidFill>
+                  <a:schemeClr val="accent2"/>
+                </a:solidFill>
+              </a:rPr>
+              <a:t>STEP 1</a:t>
+            </a:r>
+            <a:endParaRPr lang="en-US" sz="1100" dirty="0"/>
+          </a:p>
+        </p:txBody>
+      </p:sp>
+      <p:sp>
+        <p:nvSpPr>
+          <p:cNvPr id="8" name="Text 5"/>
+          <p:cNvSpPr txBox="1"/>
+          <p:nvPr/>
+        </p:nvSpPr>
+        <p:spPr>
+          <a:xfrm>
+            <a:off x="640080" y="2743200"/>
+            <a:ext cx="2103120" cy="365760"/>
+          </a:xfrm>
+          <a:prstGeom prst="rect">
+            <a:avLst/>
+          </a:prstGeom>
+          <a:noFill/>
+          <a:ln/>
+        </p:spPr>
+        <p:txBody>
+          <a:bodyPr wrap="square" lIns="0" tIns="0" rIns="0" bIns="0" rtlCol="0" anchor="t"/>
+          <a:lstStyle/>
+          <a:p>
+            <a:pPr algn="ctr" indent="0" marL="0">
+              <a:buNone/>
+            </a:pPr>
+            <a:r>
+              <a:rPr lang="en-US" sz="1600" b="1" dirty="0">
+                <a:solidFill>
+                  <a:schemeClr val="tx2"/>
+                </a:solidFill>
+              </a:rPr>
+              <a:t>お試し購入</a:t>
+            </a:r>
+            <a:endParaRPr lang="en-US" sz="1600" dirty="0"/>
+          </a:p>
+        </p:txBody>
+      </p:sp>
+      <p:sp>
+        <p:nvSpPr>
+          <p:cNvPr id="9" name="Text 6"/>
+          <p:cNvSpPr txBox="1"/>
+          <p:nvPr/>
+        </p:nvSpPr>
+        <p:spPr>
+          <a:xfrm>
+            <a:off x="640080" y="3108960"/>
+            <a:ext cx="2103120" cy="502920"/>
+          </a:xfrm>
+          <a:prstGeom prst="rect">
+            <a:avLst/>
+          </a:prstGeom>
+          <a:noFill/>
+          <a:ln/>
+        </p:spPr>
+        <p:txBody>
+          <a:bodyPr wrap="square" lIns="0" tIns="0" rIns="0" bIns="0" rtlCol="0" anchor="t"/>
+          <a:lstStyle/>
+          <a:p>
+            <a:pPr algn="ctr" indent="0" marL="0">
+              <a:buNone/>
+            </a:pPr>
+            <a:r>
+              <a:rPr lang="en-US" sz="1200" dirty="0">
+                <a:solidFill>
+                  <a:schemeClr val="tx1"/>
+                </a:solidFill>
+              </a:rPr>
+              <a:t>2種類を少量ずつ</a:t>
+            </a:r>
+            <a:endParaRPr lang="en-US" sz="1200" dirty="0"/>
+          </a:p>
+          <a:p>
+            <a:pPr algn="ctr" indent="0" marL="0">
+              <a:buNone/>
+            </a:pPr>
+            <a:r>
+              <a:rPr lang="en-US" sz="1200" dirty="0">
+                <a:solidFill>
+                  <a:schemeClr val="tx1"/>
+                </a:solidFill>
+              </a:rPr>
+              <a:t>ご購入いただく</a:t>
+            </a:r>
+            <a:endParaRPr lang="en-US" sz="1200" dirty="0"/>
+          </a:p>
+        </p:txBody>
+      </p:sp>
+      <p:pic>
+        <p:nvPicPr>
+          <p:cNvPr id="10" name="Step arrow" descr="次へ">    </p:cNvPr>
+          <p:cNvPicPr>
+            <a:picLocks noChangeAspect="1"/>
+          </p:cNvPicPr>
+          <p:nvPr/>
+        </p:nvPicPr>
+        <p:blipFill>
+          <a:blip r:embed="rId2"/>
+          <a:stretch>
+            <a:fillRect/>
+          </a:stretch>
+        </p:blipFill>
+        <p:spPr>
+          <a:xfrm>
+            <a:off x="3017520" y="2377440"/>
+            <a:ext cx="274320" cy="274320"/>
+          </a:xfrm>
+          <a:prstGeom prst="rect">
+            <a:avLst/>
+          </a:prstGeom>
+        </p:spPr>
+      </p:pic>
+      <p:sp>
+        <p:nvSpPr>
+          <p:cNvPr id="11" name="Step card"/>
           <p:cNvSpPr/>
           <p:nvPr/>
         </p:nvSpPr>
         <p:spPr>
           <a:xfrm>
-            <a:off x="5120640" y="1371600"/>
-            <a:ext cx="3200400" cy="1828800"/>
+            <a:off x="3337560" y="1371600"/>
+            <a:ext cx="2468880" cy="2286000"/>
           </a:xfrm>
           <a:prstGeom prst="roundRect">
             <a:avLst>
-              <a:gd name="adj" fmla="val 6000"/>
+              <a:gd name="adj" fmla="val 4800"/>
             </a:avLst>
           </a:prstGeom>
           <a:solidFill>
-            <a:schemeClr val="accent2"/>
+            <a:schemeClr val="bg2"/>
           </a:solidFill>
           <a:ln/>
           <a:effectLst>
@@ -4819,105 +5053,29 @@
           </a:effectLst>
         </p:spPr>
       </p:sp>
+      <p:sp>
+        <p:nvSpPr>
+          <p:cNvPr id="12" name="使用状況の確認 circle"/>
+          <p:cNvSpPr/>
+          <p:nvPr/>
+        </p:nvSpPr>
+        <p:spPr>
+          <a:xfrm>
+            <a:off x="4206240" y="1600200"/>
+            <a:ext cx="731520" cy="731520"/>
+          </a:xfrm>
+          <a:prstGeom prst="ellipse">
+            <a:avLst/>
+          </a:prstGeom>
+          <a:solidFill>
+            <a:schemeClr val="accent2"/>
+          </a:solidFill>
+          <a:ln/>
+        </p:spPr>
+      </p:sp>
       <p:pic>
         <p:nvPicPr>
-          <p:cNvPr id="9" name="Trial icon" descr="高品質タイプ">    </p:cNvPr>
-          <p:cNvPicPr>
-            <a:picLocks noChangeAspect="1"/>
-          </p:cNvPicPr>
-          <p:nvPr/>
-        </p:nvPicPr>
-        <p:blipFill>
-          <a:blip r:embed="rId2"/>
-          <a:stretch>
-            <a:fillRect/>
-          </a:stretch>
-        </p:blipFill>
-        <p:spPr>
-          <a:xfrm>
-            <a:off x="5394960" y="1600200"/>
-            <a:ext cx="548640" cy="548640"/>
-          </a:xfrm>
-          <a:prstGeom prst="rect">
-            <a:avLst/>
-          </a:prstGeom>
-        </p:spPr>
-      </p:pic>
-      <p:sp>
-        <p:nvSpPr>
-          <p:cNvPr id="10" name="Text 6"/>
-          <p:cNvSpPr txBox="1"/>
-          <p:nvPr/>
-        </p:nvSpPr>
-        <p:spPr>
-          <a:xfrm>
-            <a:off x="5394960" y="2286000"/>
-            <a:ext cx="2743200" cy="320040"/>
-          </a:xfrm>
-          <a:prstGeom prst="rect">
-            <a:avLst/>
-          </a:prstGeom>
-          <a:noFill/>
-          <a:ln/>
-        </p:spPr>
-        <p:txBody>
-          <a:bodyPr wrap="square" lIns="0" tIns="0" rIns="0" bIns="0" rtlCol="0" anchor="t"/>
-          <a:lstStyle/>
-          <a:p>
-            <a:pPr indent="0" marL="0">
-              <a:buNone/>
-            </a:pPr>
-            <a:r>
-              <a:rPr lang="en-US" sz="1300" dirty="0">
-                <a:solidFill>
-                  <a:schemeClr val="bg1"/>
-                </a:solidFill>
-              </a:rPr>
-              <a:t>鼻をかむとき用</a:t>
-            </a:r>
-            <a:endParaRPr lang="en-US" sz="1300" dirty="0"/>
-          </a:p>
-        </p:txBody>
-      </p:sp>
-      <p:sp>
-        <p:nvSpPr>
-          <p:cNvPr id="11" name="Text 7"/>
-          <p:cNvSpPr txBox="1"/>
-          <p:nvPr/>
-        </p:nvSpPr>
-        <p:spPr>
-          <a:xfrm>
-            <a:off x="5394960" y="2606040"/>
-            <a:ext cx="2743200" cy="411480"/>
-          </a:xfrm>
-          <a:prstGeom prst="rect">
-            <a:avLst/>
-          </a:prstGeom>
-          <a:noFill/>
-          <a:ln/>
-        </p:spPr>
-        <p:txBody>
-          <a:bodyPr wrap="square" lIns="0" tIns="0" rIns="0" bIns="0" rtlCol="0" anchor="t"/>
-          <a:lstStyle/>
-          <a:p>
-            <a:pPr indent="0" marL="0">
-              <a:buNone/>
-            </a:pPr>
-            <a:r>
-              <a:rPr lang="en-US" sz="2000" b="1" dirty="0">
-                <a:solidFill>
-                  <a:schemeClr val="bg1"/>
-                </a:solidFill>
-              </a:rPr>
-              <a:t>高品質タイプ</a:t>
-            </a:r>
-            <a:endParaRPr lang="en-US" sz="2000" dirty="0"/>
-          </a:p>
-        </p:txBody>
-      </p:sp>
-      <p:pic>
-        <p:nvPicPr>
-          <p:cNvPr id="12" name="Plus" descr="プラス">    </p:cNvPr>
+          <p:cNvPr id="13" name="使用状況の確認 icon" descr="使用状況の確認">    </p:cNvPr>
           <p:cNvPicPr>
             <a:picLocks noChangeAspect="1"/>
           </p:cNvPicPr>
@@ -4931,8 +5089,8 @@
         </p:blipFill>
         <p:spPr>
           <a:xfrm>
-            <a:off x="4343400" y="2057400"/>
-            <a:ext cx="457200" cy="457200"/>
+            <a:off x="4389120" y="1783080"/>
+            <a:ext cx="365760" cy="365760"/>
           </a:xfrm>
           <a:prstGeom prst="rect">
             <a:avLst/>
@@ -4941,14 +5099,14 @@
       </p:pic>
       <p:sp>
         <p:nvSpPr>
-          <p:cNvPr id="13" name="Text 8"/>
+          <p:cNvPr id="14" name="Text 9"/>
           <p:cNvSpPr txBox="1"/>
           <p:nvPr/>
         </p:nvSpPr>
         <p:spPr>
           <a:xfrm>
-            <a:off x="822960" y="3566160"/>
-            <a:ext cx="7498080" cy="457200"/>
+            <a:off x="3520440" y="2468880"/>
+            <a:ext cx="2103120" cy="274320"/>
           </a:xfrm>
           <a:prstGeom prst="rect">
             <a:avLst/>
@@ -4964,14 +5122,355 @@
               <a:buNone/>
             </a:pPr>
             <a:r>
+              <a:rPr lang="en-US" sz="1100" b="1" dirty="0">
+                <a:solidFill>
+                  <a:schemeClr val="accent2"/>
+                </a:solidFill>
+              </a:rPr>
+              <a:t>STEP 2</a:t>
+            </a:r>
+            <a:endParaRPr lang="en-US" sz="1100" dirty="0"/>
+          </a:p>
+        </p:txBody>
+      </p:sp>
+      <p:sp>
+        <p:nvSpPr>
+          <p:cNvPr id="15" name="Text 10"/>
+          <p:cNvSpPr txBox="1"/>
+          <p:nvPr/>
+        </p:nvSpPr>
+        <p:spPr>
+          <a:xfrm>
+            <a:off x="3520440" y="2743200"/>
+            <a:ext cx="2103120" cy="365760"/>
+          </a:xfrm>
+          <a:prstGeom prst="rect">
+            <a:avLst/>
+          </a:prstGeom>
+          <a:noFill/>
+          <a:ln/>
+        </p:spPr>
+        <p:txBody>
+          <a:bodyPr wrap="square" lIns="0" tIns="0" rIns="0" bIns="0" rtlCol="0" anchor="t"/>
+          <a:lstStyle/>
+          <a:p>
+            <a:pPr algn="ctr" indent="0" marL="0">
+              <a:buNone/>
+            </a:pPr>
+            <a:r>
               <a:rPr lang="en-US" sz="1600" b="1" dirty="0">
                 <a:solidFill>
                   <a:schemeClr val="tx2"/>
                 </a:solidFill>
               </a:rPr>
-              <a:t>価格だけでも、品質だけでもなく、お客様の生活に合った商品を。</a:t>
+              <a:t>使用状況の確認</a:t>
             </a:r>
             <a:endParaRPr lang="en-US" sz="1600" dirty="0"/>
+          </a:p>
+        </p:txBody>
+      </p:sp>
+      <p:sp>
+        <p:nvSpPr>
+          <p:cNvPr id="16" name="Text 11"/>
+          <p:cNvSpPr txBox="1"/>
+          <p:nvPr/>
+        </p:nvSpPr>
+        <p:spPr>
+          <a:xfrm>
+            <a:off x="3520440" y="3108960"/>
+            <a:ext cx="2103120" cy="502920"/>
+          </a:xfrm>
+          <a:prstGeom prst="rect">
+            <a:avLst/>
+          </a:prstGeom>
+          <a:noFill/>
+          <a:ln/>
+        </p:spPr>
+        <p:txBody>
+          <a:bodyPr wrap="square" lIns="0" tIns="0" rIns="0" bIns="0" rtlCol="0" anchor="t"/>
+          <a:lstStyle/>
+          <a:p>
+            <a:pPr algn="ctr" indent="0" marL="0">
+              <a:buNone/>
+            </a:pPr>
+            <a:r>
+              <a:rPr lang="en-US" sz="1200" dirty="0">
+                <a:solidFill>
+                  <a:schemeClr val="tx1"/>
+                </a:solidFill>
+              </a:rPr>
+              <a:t>使用量や社員・来客の</a:t>
+            </a:r>
+            <a:endParaRPr lang="en-US" sz="1200" dirty="0"/>
+          </a:p>
+          <a:p>
+            <a:pPr algn="ctr" indent="0" marL="0">
+              <a:buNone/>
+            </a:pPr>
+            <a:r>
+              <a:rPr lang="en-US" sz="1200" dirty="0">
+                <a:solidFill>
+                  <a:schemeClr val="tx1"/>
+                </a:solidFill>
+              </a:rPr>
+              <a:t>使い心地を確認</a:t>
+            </a:r>
+            <a:endParaRPr lang="en-US" sz="1200" dirty="0"/>
+          </a:p>
+        </p:txBody>
+      </p:sp>
+      <p:pic>
+        <p:nvPicPr>
+          <p:cNvPr id="17" name="Step arrow" descr="次へ">    </p:cNvPr>
+          <p:cNvPicPr>
+            <a:picLocks noChangeAspect="1"/>
+          </p:cNvPicPr>
+          <p:nvPr/>
+        </p:nvPicPr>
+        <p:blipFill>
+          <a:blip r:embed="rId4"/>
+          <a:stretch>
+            <a:fillRect/>
+          </a:stretch>
+        </p:blipFill>
+        <p:spPr>
+          <a:xfrm>
+            <a:off x="5897880" y="2377440"/>
+            <a:ext cx="274320" cy="274320"/>
+          </a:xfrm>
+          <a:prstGeom prst="rect">
+            <a:avLst/>
+          </a:prstGeom>
+        </p:spPr>
+      </p:pic>
+      <p:sp>
+        <p:nvSpPr>
+          <p:cNvPr id="18" name="Step card"/>
+          <p:cNvSpPr/>
+          <p:nvPr/>
+        </p:nvSpPr>
+        <p:spPr>
+          <a:xfrm>
+            <a:off x="6217920" y="1371600"/>
+            <a:ext cx="2468880" cy="2286000"/>
+          </a:xfrm>
+          <a:prstGeom prst="roundRect">
+            <a:avLst>
+              <a:gd name="adj" fmla="val 4800"/>
+            </a:avLst>
+          </a:prstGeom>
+          <a:solidFill>
+            <a:schemeClr val="bg2"/>
+          </a:solidFill>
+          <a:ln/>
+          <a:effectLst>
+            <a:outerShdw sx="100000" sy="100000" kx="0" ky="0" algn="bl" rotWithShape="0" blurRad="76200" dist="25400" dir="5400000">
+              <a:srgbClr val="000000">
+                <a:alpha val="12000"/>
+              </a:srgbClr>
+            </a:outerShdw>
+          </a:effectLst>
+        </p:spPr>
+      </p:sp>
+      <p:sp>
+        <p:nvSpPr>
+          <p:cNvPr id="19" name="本格導入 circle"/>
+          <p:cNvSpPr/>
+          <p:nvPr/>
+        </p:nvSpPr>
+        <p:spPr>
+          <a:xfrm>
+            <a:off x="7086600" y="1600200"/>
+            <a:ext cx="731520" cy="731520"/>
+          </a:xfrm>
+          <a:prstGeom prst="ellipse">
+            <a:avLst/>
+          </a:prstGeom>
+          <a:solidFill>
+            <a:schemeClr val="tx2"/>
+          </a:solidFill>
+          <a:ln/>
+        </p:spPr>
+      </p:sp>
+      <p:pic>
+        <p:nvPicPr>
+          <p:cNvPr id="20" name="本格導入 icon" descr="本格導入">    </p:cNvPr>
+          <p:cNvPicPr>
+            <a:picLocks noChangeAspect="1"/>
+          </p:cNvPicPr>
+          <p:nvPr/>
+        </p:nvPicPr>
+        <p:blipFill>
+          <a:blip r:embed="rId5"/>
+          <a:stretch>
+            <a:fillRect/>
+          </a:stretch>
+        </p:blipFill>
+        <p:spPr>
+          <a:xfrm>
+            <a:off x="7269480" y="1783080"/>
+            <a:ext cx="365760" cy="365760"/>
+          </a:xfrm>
+          <a:prstGeom prst="rect">
+            <a:avLst/>
+          </a:prstGeom>
+        </p:spPr>
+      </p:pic>
+      <p:sp>
+        <p:nvSpPr>
+          <p:cNvPr id="21" name="Text 14"/>
+          <p:cNvSpPr txBox="1"/>
+          <p:nvPr/>
+        </p:nvSpPr>
+        <p:spPr>
+          <a:xfrm>
+            <a:off x="6400800" y="2468880"/>
+            <a:ext cx="2103120" cy="274320"/>
+          </a:xfrm>
+          <a:prstGeom prst="rect">
+            <a:avLst/>
+          </a:prstGeom>
+          <a:noFill/>
+          <a:ln/>
+        </p:spPr>
+        <p:txBody>
+          <a:bodyPr wrap="square" lIns="0" tIns="0" rIns="0" bIns="0" rtlCol="0" anchor="t"/>
+          <a:lstStyle/>
+          <a:p>
+            <a:pPr algn="ctr" indent="0" marL="0">
+              <a:buNone/>
+            </a:pPr>
+            <a:r>
+              <a:rPr lang="en-US" sz="1100" b="1" dirty="0">
+                <a:solidFill>
+                  <a:schemeClr val="accent2"/>
+                </a:solidFill>
+              </a:rPr>
+              <a:t>STEP 3</a:t>
+            </a:r>
+            <a:endParaRPr lang="en-US" sz="1100" dirty="0"/>
+          </a:p>
+        </p:txBody>
+      </p:sp>
+      <p:sp>
+        <p:nvSpPr>
+          <p:cNvPr id="22" name="Text 15"/>
+          <p:cNvSpPr txBox="1"/>
+          <p:nvPr/>
+        </p:nvSpPr>
+        <p:spPr>
+          <a:xfrm>
+            <a:off x="6400800" y="2743200"/>
+            <a:ext cx="2103120" cy="365760"/>
+          </a:xfrm>
+          <a:prstGeom prst="rect">
+            <a:avLst/>
+          </a:prstGeom>
+          <a:noFill/>
+          <a:ln/>
+        </p:spPr>
+        <p:txBody>
+          <a:bodyPr wrap="square" lIns="0" tIns="0" rIns="0" bIns="0" rtlCol="0" anchor="t"/>
+          <a:lstStyle/>
+          <a:p>
+            <a:pPr algn="ctr" indent="0" marL="0">
+              <a:buNone/>
+            </a:pPr>
+            <a:r>
+              <a:rPr lang="en-US" sz="1600" b="1" dirty="0">
+                <a:solidFill>
+                  <a:schemeClr val="tx2"/>
+                </a:solidFill>
+              </a:rPr>
+              <a:t>本格導入</a:t>
+            </a:r>
+            <a:endParaRPr lang="en-US" sz="1600" dirty="0"/>
+          </a:p>
+        </p:txBody>
+      </p:sp>
+      <p:sp>
+        <p:nvSpPr>
+          <p:cNvPr id="23" name="Text 16"/>
+          <p:cNvSpPr txBox="1"/>
+          <p:nvPr/>
+        </p:nvSpPr>
+        <p:spPr>
+          <a:xfrm>
+            <a:off x="6400800" y="3108960"/>
+            <a:ext cx="2103120" cy="502920"/>
+          </a:xfrm>
+          <a:prstGeom prst="rect">
+            <a:avLst/>
+          </a:prstGeom>
+          <a:noFill/>
+          <a:ln/>
+        </p:spPr>
+        <p:txBody>
+          <a:bodyPr wrap="square" lIns="0" tIns="0" rIns="0" bIns="0" rtlCol="0" anchor="t"/>
+          <a:lstStyle/>
+          <a:p>
+            <a:pPr algn="ctr" indent="0" marL="0">
+              <a:buNone/>
+            </a:pPr>
+            <a:r>
+              <a:rPr lang="en-US" sz="1200" dirty="0">
+                <a:solidFill>
+                  <a:schemeClr val="tx1"/>
+                </a:solidFill>
+              </a:rPr>
+              <a:t>配分を最適化して</a:t>
+            </a:r>
+            <a:endParaRPr lang="en-US" sz="1200" dirty="0"/>
+          </a:p>
+          <a:p>
+            <a:pPr algn="ctr" indent="0" marL="0">
+              <a:buNone/>
+            </a:pPr>
+            <a:r>
+              <a:rPr lang="en-US" sz="1200" dirty="0">
+                <a:solidFill>
+                  <a:schemeClr val="tx1"/>
+                </a:solidFill>
+              </a:rPr>
+              <a:t>定期的にお届け</a:t>
+            </a:r>
+            <a:endParaRPr lang="en-US" sz="1200" dirty="0"/>
+          </a:p>
+        </p:txBody>
+      </p:sp>
+      <p:sp>
+        <p:nvSpPr>
+          <p:cNvPr id="24" name="Text 17"/>
+          <p:cNvSpPr txBox="1"/>
+          <p:nvPr/>
+        </p:nvSpPr>
+        <p:spPr>
+          <a:xfrm>
+            <a:off x="457200" y="3931920"/>
+            <a:ext cx="8229600" cy="365760"/>
+          </a:xfrm>
+          <a:prstGeom prst="rect">
+            <a:avLst/>
+          </a:prstGeom>
+          <a:noFill/>
+          <a:ln/>
+        </p:spPr>
+        <p:txBody>
+          <a:bodyPr wrap="square" lIns="0" tIns="0" rIns="0" bIns="0" rtlCol="0" anchor="t"/>
+          <a:lstStyle/>
+          <a:p>
+            <a:pPr algn="ctr" indent="0" marL="0">
+              <a:buNone/>
+            </a:pPr>
+            <a:r>
+              <a:rPr lang="en-US" sz="1400" b="1" dirty="0">
+                <a:solidFill>
+                  <a:schemeClr val="tx2"/>
+                </a:solidFill>
+              </a:rPr>
+              <a:t>コスト削減と品質のバランスは、貴社のご予算・使用量に合わせて調整します</a:t>
+            </a:r>
+            <a:endParaRPr lang="en-US" sz="1400" dirty="0"/>
           </a:p>
         </p:txBody>
       </p:sp>
@@ -5101,7 +5600,7 @@
                   <a:schemeClr val="bg1"/>
                 </a:solidFill>
               </a:rPr>
-              <a:t>お客様が大切にしていることを伺い、</a:t>
+              <a:t>コストと品質、</a:t>
             </a:r>
             <a:endParaRPr lang="en-US" sz="3600" dirty="0"/>
           </a:p>
@@ -5115,7 +5614,7 @@
                   <a:schemeClr val="bg1"/>
                 </a:solidFill>
               </a:rPr>
-              <a:t>その方に合った価値をご提案する</a:t>
+              <a:t>貴社にとって最適なバランスを</a:t>
             </a:r>
             <a:endParaRPr lang="en-US" sz="3600" dirty="0"/>
           </a:p>
@@ -5153,7 +5652,21 @@
                   <a:schemeClr val="accent6"/>
                 </a:solidFill>
               </a:rPr>
-              <a:t>商品の良さを一方的にお伝えするのではなく、お客様の想いに寄り添う営業を心がけています。</a:t>
+              <a:t>現在の使用状況や課題を伺い、</a:t>
+            </a:r>
+            <a:endParaRPr lang="en-US" sz="1800" dirty="0"/>
+          </a:p>
+          <a:p>
+            <a:pPr algn="l" indent="0" marL="0">
+              <a:buNone/>
+            </a:pPr>
+            <a:r>
+              <a:rPr lang="en-US" sz="1800" dirty="0">
+                <a:solidFill>
+                  <a:schemeClr val="accent6"/>
+                </a:solidFill>
+              </a:rPr>
+              <a:t>ご予算・使用量・用途に合ったご提案をいたします。</a:t>
             </a:r>
             <a:endParaRPr lang="en-US" sz="1800" dirty="0"/>
           </a:p>

</xml_diff>